<commit_message>
Update ERS navy theme and OIB presentation materials
</commit_message>
<xml_diff>
--- a/02 Osnove Informacione Bezbednosti/02 Prezentacije/PPTX/00_Osnovne_informacije.pptx
+++ b/02 Osnove Informacione Bezbednosti/02 Prezentacije/PPTX/00_Osnovne_informacije.pptx
@@ -2,32 +2,32 @@
 <file path=ppt/presentation.xml><?xml version="1.0" encoding="utf-8"?>
 <p:presentation xmlns:p="http://schemas.openxmlformats.org/presentationml/2006/main">
   <p:sldMasterIdLst>
-    <p:sldMasterId xmlns:r="http://schemas.openxmlformats.org/officeDocument/2006/relationships" id="2147483648" r:id="R5fc467e6bae9490b"/>
+    <p:sldMasterId xmlns:r="http://schemas.openxmlformats.org/officeDocument/2006/relationships" id="2147483648" r:id="R55864bcb9a8e44b1"/>
   </p:sldMasterIdLst>
   <p:notesMasterIdLst>
-    <p:notesMasterId xmlns:r="http://schemas.openxmlformats.org/officeDocument/2006/relationships" r:id="R21960c57327e46a3"/>
+    <p:notesMasterId xmlns:r="http://schemas.openxmlformats.org/officeDocument/2006/relationships" r:id="R9b2dfbc968a54502"/>
   </p:notesMasterIdLst>
   <p:sldIdLst>
-    <p:sldId xmlns:r="http://schemas.openxmlformats.org/officeDocument/2006/relationships" id="256" r:id="R1f5b821058044fcd"/>
-    <p:sldId xmlns:r="http://schemas.openxmlformats.org/officeDocument/2006/relationships" id="257" r:id="R302797cb87854d87"/>
-    <p:sldId xmlns:r="http://schemas.openxmlformats.org/officeDocument/2006/relationships" id="258" r:id="Rad4cac010a6e4110"/>
-    <p:sldId xmlns:r="http://schemas.openxmlformats.org/officeDocument/2006/relationships" id="259" r:id="R734c51ea648d4e47"/>
-    <p:sldId xmlns:r="http://schemas.openxmlformats.org/officeDocument/2006/relationships" id="260" r:id="Ra65fa925cf814cb3"/>
-    <p:sldId xmlns:r="http://schemas.openxmlformats.org/officeDocument/2006/relationships" id="261" r:id="R6d21dd63f40547fc"/>
-    <p:sldId xmlns:r="http://schemas.openxmlformats.org/officeDocument/2006/relationships" id="262" r:id="R45a9cc8851e4461a"/>
-    <p:sldId xmlns:r="http://schemas.openxmlformats.org/officeDocument/2006/relationships" id="263" r:id="Rd365d9cb44a64a46"/>
-    <p:sldId xmlns:r="http://schemas.openxmlformats.org/officeDocument/2006/relationships" id="264" r:id="R0956b9ff039d4650"/>
-    <p:sldId xmlns:r="http://schemas.openxmlformats.org/officeDocument/2006/relationships" id="265" r:id="R886f71d6991e4911"/>
-    <p:sldId xmlns:r="http://schemas.openxmlformats.org/officeDocument/2006/relationships" id="266" r:id="R4836ddf2edc94659"/>
-    <p:sldId xmlns:r="http://schemas.openxmlformats.org/officeDocument/2006/relationships" id="267" r:id="Reefac2b93c1c4feb"/>
-    <p:sldId xmlns:r="http://schemas.openxmlformats.org/officeDocument/2006/relationships" id="268" r:id="R87197549a67940d9"/>
-    <p:sldId xmlns:r="http://schemas.openxmlformats.org/officeDocument/2006/relationships" id="269" r:id="Rcb938c5c7fca45ac"/>
-    <p:sldId xmlns:r="http://schemas.openxmlformats.org/officeDocument/2006/relationships" id="270" r:id="R87ad8f4401c0431c"/>
-    <p:sldId xmlns:r="http://schemas.openxmlformats.org/officeDocument/2006/relationships" id="271" r:id="R6763c524477841f3"/>
-    <p:sldId xmlns:r="http://schemas.openxmlformats.org/officeDocument/2006/relationships" id="272" r:id="R968e7cacbd054962"/>
-    <p:sldId xmlns:r="http://schemas.openxmlformats.org/officeDocument/2006/relationships" id="273" r:id="R37ff372089b74089"/>
-    <p:sldId xmlns:r="http://schemas.openxmlformats.org/officeDocument/2006/relationships" id="274" r:id="Rebf1112d7be04a02"/>
-    <p:sldId xmlns:r="http://schemas.openxmlformats.org/officeDocument/2006/relationships" id="275" r:id="R4a1626f2ae304cf7"/>
+    <p:sldId xmlns:r="http://schemas.openxmlformats.org/officeDocument/2006/relationships" id="256" r:id="R0509dc1c3ae043bc"/>
+    <p:sldId xmlns:r="http://schemas.openxmlformats.org/officeDocument/2006/relationships" id="257" r:id="Ra088c258524d4518"/>
+    <p:sldId xmlns:r="http://schemas.openxmlformats.org/officeDocument/2006/relationships" id="258" r:id="R9a090b87d0b34050"/>
+    <p:sldId xmlns:r="http://schemas.openxmlformats.org/officeDocument/2006/relationships" id="259" r:id="Rdca74eb0863e4c58"/>
+    <p:sldId xmlns:r="http://schemas.openxmlformats.org/officeDocument/2006/relationships" id="260" r:id="Rbc276ee21dc043cf"/>
+    <p:sldId xmlns:r="http://schemas.openxmlformats.org/officeDocument/2006/relationships" id="261" r:id="Rd1dac7fd022943ae"/>
+    <p:sldId xmlns:r="http://schemas.openxmlformats.org/officeDocument/2006/relationships" id="262" r:id="R2f1de67b155b4cd8"/>
+    <p:sldId xmlns:r="http://schemas.openxmlformats.org/officeDocument/2006/relationships" id="263" r:id="R023e1cac617640f9"/>
+    <p:sldId xmlns:r="http://schemas.openxmlformats.org/officeDocument/2006/relationships" id="264" r:id="R23d59d3c693943bc"/>
+    <p:sldId xmlns:r="http://schemas.openxmlformats.org/officeDocument/2006/relationships" id="265" r:id="R45b3f80d498245c7"/>
+    <p:sldId xmlns:r="http://schemas.openxmlformats.org/officeDocument/2006/relationships" id="266" r:id="R6e4752a53d264ac9"/>
+    <p:sldId xmlns:r="http://schemas.openxmlformats.org/officeDocument/2006/relationships" id="267" r:id="R01d3be826ec24e97"/>
+    <p:sldId xmlns:r="http://schemas.openxmlformats.org/officeDocument/2006/relationships" id="268" r:id="Re804c1c112c34c78"/>
+    <p:sldId xmlns:r="http://schemas.openxmlformats.org/officeDocument/2006/relationships" id="269" r:id="R7eed0e2909104223"/>
+    <p:sldId xmlns:r="http://schemas.openxmlformats.org/officeDocument/2006/relationships" id="270" r:id="Rc98e57076415406d"/>
+    <p:sldId xmlns:r="http://schemas.openxmlformats.org/officeDocument/2006/relationships" id="271" r:id="R05e29e6b756047ea"/>
+    <p:sldId xmlns:r="http://schemas.openxmlformats.org/officeDocument/2006/relationships" id="272" r:id="Rd5f2db4b17bf4840"/>
+    <p:sldId xmlns:r="http://schemas.openxmlformats.org/officeDocument/2006/relationships" id="273" r:id="Rb1116aa51ae14a56"/>
+    <p:sldId xmlns:r="http://schemas.openxmlformats.org/officeDocument/2006/relationships" id="274" r:id="R8cd804fd8e024c25"/>
+    <p:sldId xmlns:r="http://schemas.openxmlformats.org/officeDocument/2006/relationships" id="275" r:id="Rc3966107cb53417b"/>
   </p:sldIdLst>
   <p:sldSz cx="12192000" cy="6858000"/>
   <p:notesSz cx="6858000" cy="9144000"/>
@@ -1868,7 +1868,7 @@
   </p:cSld>
   <p:clrMap bg1="lt1" tx1="dk1" bg2="lt2" tx2="dk2" accent1="accent1" accent2="accent2" accent3="accent3" accent4="accent4" accent5="accent5" accent6="accent6" hlink="hlink" folHlink="folHlink"/>
   <p:sldLayoutIdLst>
-    <p:sldLayoutId xmlns:r="http://schemas.openxmlformats.org/officeDocument/2006/relationships" id="2147483649" r:id="Rf8797d342fa947c0"/>
+    <p:sldLayoutId xmlns:r="http://schemas.openxmlformats.org/officeDocument/2006/relationships" id="2147483649" r:id="R045d13e3684e482a"/>
   </p:sldLayoutIdLst>
   <p:txStyles>
     <p:titleStyle>
@@ -2509,7 +2509,7 @@
           <a:noFill xmlns:a="http://schemas.openxmlformats.org/drawingml/2006/main"/>
           <a:ln xmlns:a="http://schemas.openxmlformats.org/drawingml/2006/main" w="8573">
             <a:solidFill>
-              <a:srgbClr val="7F8B9B"/>
+              <a:srgbClr val="8D5560"/>
             </a:solidFill>
             <a:prstDash val="solid"/>
           </a:ln>
@@ -2540,7 +2540,7 @@
             </a:avLst>
           </a:prstGeom>
           <a:solidFill xmlns:a="http://schemas.openxmlformats.org/drawingml/2006/main">
-            <a:srgbClr val="315CF4"/>
+            <a:srgbClr val="7A2636"/>
           </a:solidFill>
           <a:ln xmlns:a="http://schemas.openxmlformats.org/drawingml/2006/main" w="0">
             <a:noFill/>
@@ -2722,7 +2722,7 @@
         </p:spPr>
         <p:txBody>
           <a:bodyPr xmlns:a="http://schemas.openxmlformats.org/drawingml/2006/main" wrap="square" lIns="0" tIns="0" rIns="0" bIns="0" anchor="ctr">
-            <a:normAutofit/>
+            <a:normAutofit fontScale="100000"/>
           </a:bodyPr>
           <a:lstStyle xmlns:a="http://schemas.openxmlformats.org/drawingml/2006/main"/>
           <a:p xmlns:a="http://schemas.openxmlformats.org/drawingml/2006/main">
@@ -2749,7 +2749,7 @@
                 <a:ea typeface="Aptos"/>
                 <a:cs typeface="Aptos"/>
               </a:rPr>
-              <a:t>Начин рада, правила полагања и ток практичних вежби</a:t>
+              <a:t>Организација наставе, начини полагања и пројектне обавезе</a:t>
             </a:r>
           </a:p>
         </p:txBody>
@@ -2777,9 +2777,9 @@
             <a:avLst/>
           </a:prstGeom>
           <a:noFill xmlns:a="http://schemas.openxmlformats.org/drawingml/2006/main"/>
-          <a:ln xmlns:a="http://schemas.openxmlformats.org/drawingml/2006/main" w="9525">
+          <a:ln xmlns:a="http://schemas.openxmlformats.org/drawingml/2006/main" w="8573">
             <a:solidFill>
-              <a:srgbClr val="CBD5E1"/>
+              <a:srgbClr val="8D5560"/>
             </a:solidFill>
             <a:prstDash val="solid"/>
           </a:ln>
@@ -2802,7 +2802,7 @@
         <p:spPr>
           <a:xfrm xmlns:a="http://schemas.openxmlformats.org/drawingml/2006/main">
             <a:off x="914400" y="5581650"/>
-            <a:ext cx="4000500" cy="247650"/>
+            <a:ext cx="6191250" cy="247650"/>
           </a:xfrm>
           <a:prstGeom xmlns:a="http://schemas.openxmlformats.org/drawingml/2006/main" prst="rect">
             <a:avLst/>
@@ -2814,7 +2814,7 @@
         </p:spPr>
         <p:txBody>
           <a:bodyPr xmlns:a="http://schemas.openxmlformats.org/drawingml/2006/main" wrap="square" lIns="0" tIns="0" rIns="0" bIns="0" anchor="t">
-            <a:normAutofit/>
+            <a:normAutofit fontScale="100000"/>
           </a:bodyPr>
           <a:lstStyle xmlns:a="http://schemas.openxmlformats.org/drawingml/2006/main"/>
           <a:p xmlns:a="http://schemas.openxmlformats.org/drawingml/2006/main">
@@ -2833,7 +2833,7 @@
               </a:defRPr>
             </a:pPr>
             <a:r>
-              <a:rPr sz="1200" b="1">
+              <a:rPr sz="1125" b="0">
                 <a:solidFill>
                   <a:srgbClr val="1A202C"/>
                 </a:solidFill>
@@ -2841,7 +2841,7 @@
                 <a:ea typeface="Aptos"/>
                 <a:cs typeface="Aptos"/>
               </a:rPr>
-              <a:t>ОИБ · 5. семестар</a:t>
+              <a:t>Факултет техничких наука · Универзитет у Новом Саду</a:t>
             </a:r>
           </a:p>
         </p:txBody>
@@ -2875,7 +2875,7 @@
         </p:spPr>
         <p:txBody>
           <a:bodyPr xmlns:a="http://schemas.openxmlformats.org/drawingml/2006/main" wrap="square" lIns="0" tIns="0" rIns="0" bIns="0" anchor="t">
-            <a:normAutofit/>
+            <a:normAutofit fontScale="100000"/>
           </a:bodyPr>
           <a:lstStyle xmlns:a="http://schemas.openxmlformats.org/drawingml/2006/main"/>
           <a:p xmlns:a="http://schemas.openxmlformats.org/drawingml/2006/main">
@@ -2902,7 +2902,7 @@
                 <a:ea typeface="Aptos"/>
                 <a:cs typeface="Aptos"/>
               </a:rPr>
-              <a:t>Академска 2026/27</a:t>
+              <a:t>Академска 2026/27.</a:t>
             </a:r>
           </a:p>
         </p:txBody>
@@ -2965,7 +2965,7 @@
         </p:spPr>
         <p:txBody>
           <a:bodyPr xmlns:a="http://schemas.openxmlformats.org/drawingml/2006/main" wrap="square" lIns="0" tIns="0" rIns="0" bIns="0" anchor="t">
-            <a:normAutofit/>
+            <a:normAutofit fontScale="100000"/>
           </a:bodyPr>
           <a:lstStyle xmlns:a="http://schemas.openxmlformats.org/drawingml/2006/main"/>
           <a:p xmlns:a="http://schemas.openxmlformats.org/drawingml/2006/main">
@@ -2986,7 +2986,7 @@
             <a:r>
               <a:rPr sz="825" b="0">
                 <a:solidFill>
-                  <a:srgbClr val="657184"/>
+                  <a:srgbClr val="5E6B7D"/>
                 </a:solidFill>
                 <a:latin typeface="Aptos"/>
                 <a:ea typeface="Aptos"/>
@@ -3019,10 +3019,12 @@
           <a:prstGeom xmlns:a="http://schemas.openxmlformats.org/drawingml/2006/main" prst="line">
             <a:avLst/>
           </a:prstGeom>
-          <a:noFill xmlns:a="http://schemas.openxmlformats.org/drawingml/2006/main"/>
-          <a:ln xmlns:a="http://schemas.openxmlformats.org/drawingml/2006/main" w="9525">
+          <a:solidFill xmlns:a="http://schemas.openxmlformats.org/drawingml/2006/main">
+            <a:srgbClr val="8D5560"/>
+          </a:solidFill>
+          <a:ln xmlns:a="http://schemas.openxmlformats.org/drawingml/2006/main" w="7144">
             <a:solidFill>
-              <a:srgbClr val="748092"/>
+              <a:srgbClr val="8D5560"/>
             </a:solidFill>
             <a:prstDash val="solid"/>
           </a:ln>
@@ -3118,7 +3120,7 @@
         </p:spPr>
         <p:txBody>
           <a:bodyPr xmlns:a="http://schemas.openxmlformats.org/drawingml/2006/main" wrap="square" lIns="0" tIns="0" rIns="0" bIns="0" anchor="t">
-            <a:normAutofit/>
+            <a:normAutofit fontScale="100000"/>
           </a:bodyPr>
           <a:lstStyle xmlns:a="http://schemas.openxmlformats.org/drawingml/2006/main"/>
           <a:p xmlns:a="http://schemas.openxmlformats.org/drawingml/2006/main">
@@ -3145,7 +3147,7 @@
                 <a:ea typeface="Aptos Display"/>
                 <a:cs typeface="Aptos Display"/>
               </a:rPr>
-              <a:t>Присуство, интегритет и безбедан рад су обавезни</a:t>
+              <a:t>Обавезе студената и правила безбедног рада</a:t>
             </a:r>
           </a:p>
         </p:txBody>
@@ -3179,7 +3181,7 @@
         </p:spPr>
         <p:txBody>
           <a:bodyPr xmlns:a="http://schemas.openxmlformats.org/drawingml/2006/main" wrap="square" lIns="0" tIns="0" rIns="0" bIns="0" anchor="t">
-            <a:normAutofit/>
+            <a:normAutofit fontScale="100000"/>
           </a:bodyPr>
           <a:lstStyle xmlns:a="http://schemas.openxmlformats.org/drawingml/2006/main"/>
           <a:p xmlns:a="http://schemas.openxmlformats.org/drawingml/2006/main">
@@ -3206,216 +3208,7 @@
                 <a:ea typeface="Aptos"/>
                 <a:cs typeface="Aptos"/>
               </a:rPr>
-              <a:t>Правила</a:t>
-            </a:r>
-            <a:r>
-              <a:rPr sz="1575" b="0">
-                <a:solidFill>
-                  <a:srgbClr val="657184"/>
-                </a:solidFill>
-                <a:latin typeface="Aptos"/>
-                <a:ea typeface="Aptos"/>
-                <a:cs typeface="Aptos"/>
-              </a:rPr>
-              <a:t> </a:t>
-            </a:r>
-            <a:r>
-              <a:rPr sz="1575" b="0">
-                <a:solidFill>
-                  <a:srgbClr val="657184"/>
-                </a:solidFill>
-                <a:latin typeface="Aptos"/>
-                <a:ea typeface="Aptos"/>
-                <a:cs typeface="Aptos"/>
-              </a:rPr>
-              <a:t>штите</a:t>
-            </a:r>
-            <a:r>
-              <a:rPr sz="1575" b="0">
-                <a:solidFill>
-                  <a:srgbClr val="657184"/>
-                </a:solidFill>
-                <a:latin typeface="Aptos"/>
-                <a:ea typeface="Aptos"/>
-                <a:cs typeface="Aptos"/>
-              </a:rPr>
-              <a:t> </a:t>
-            </a:r>
-            <a:r>
-              <a:rPr sz="1575" b="0">
-                <a:solidFill>
-                  <a:srgbClr val="657184"/>
-                </a:solidFill>
-                <a:latin typeface="Aptos"/>
-                <a:ea typeface="Aptos"/>
-                <a:cs typeface="Aptos"/>
-              </a:rPr>
-              <a:t>и</a:t>
-            </a:r>
-            <a:r>
-              <a:rPr sz="1575" b="0">
-                <a:solidFill>
-                  <a:srgbClr val="657184"/>
-                </a:solidFill>
-                <a:latin typeface="Aptos"/>
-                <a:ea typeface="Aptos"/>
-                <a:cs typeface="Aptos"/>
-              </a:rPr>
-              <a:t> </a:t>
-            </a:r>
-            <a:r>
-              <a:rPr sz="1575" b="0">
-                <a:solidFill>
-                  <a:srgbClr val="657184"/>
-                </a:solidFill>
-                <a:latin typeface="Aptos"/>
-                <a:ea typeface="Aptos"/>
-                <a:cs typeface="Aptos"/>
-              </a:rPr>
-              <a:t>квалитет</a:t>
-            </a:r>
-            <a:r>
-              <a:rPr sz="1575" b="0">
-                <a:solidFill>
-                  <a:srgbClr val="657184"/>
-                </a:solidFill>
-                <a:latin typeface="Aptos"/>
-                <a:ea typeface="Aptos"/>
-                <a:cs typeface="Aptos"/>
-              </a:rPr>
-              <a:t> </a:t>
-            </a:r>
-            <a:r>
-              <a:rPr sz="1575" b="0">
-                <a:solidFill>
-                  <a:srgbClr val="657184"/>
-                </a:solidFill>
-                <a:latin typeface="Aptos"/>
-                <a:ea typeface="Aptos"/>
-                <a:cs typeface="Aptos"/>
-              </a:rPr>
-              <a:t>наставе</a:t>
-            </a:r>
-            <a:r>
-              <a:rPr sz="1575" b="0">
-                <a:solidFill>
-                  <a:srgbClr val="657184"/>
-                </a:solidFill>
-                <a:latin typeface="Aptos"/>
-                <a:ea typeface="Aptos"/>
-                <a:cs typeface="Aptos"/>
-              </a:rPr>
-              <a:t> </a:t>
-            </a:r>
-            <a:r>
-              <a:rPr sz="1575" b="0">
-                <a:solidFill>
-                  <a:srgbClr val="657184"/>
-                </a:solidFill>
-                <a:latin typeface="Aptos"/>
-                <a:ea typeface="Aptos"/>
-                <a:cs typeface="Aptos"/>
-              </a:rPr>
-              <a:t>и</a:t>
-            </a:r>
-            <a:r>
-              <a:rPr sz="1575" b="0">
-                <a:solidFill>
-                  <a:srgbClr val="657184"/>
-                </a:solidFill>
-                <a:latin typeface="Aptos"/>
-                <a:ea typeface="Aptos"/>
-                <a:cs typeface="Aptos"/>
-              </a:rPr>
-              <a:t> </a:t>
-            </a:r>
-            <a:r>
-              <a:rPr sz="1575" b="0">
-                <a:solidFill>
-                  <a:srgbClr val="657184"/>
-                </a:solidFill>
-                <a:latin typeface="Aptos"/>
-                <a:ea typeface="Aptos"/>
-                <a:cs typeface="Aptos"/>
-              </a:rPr>
-              <a:t>системе</a:t>
-            </a:r>
-            <a:r>
-              <a:rPr sz="1575" b="0">
-                <a:solidFill>
-                  <a:srgbClr val="657184"/>
-                </a:solidFill>
-                <a:latin typeface="Aptos"/>
-                <a:ea typeface="Aptos"/>
-                <a:cs typeface="Aptos"/>
-              </a:rPr>
-              <a:t> </a:t>
-            </a:r>
-            <a:r>
-              <a:rPr sz="1575" b="0">
-                <a:solidFill>
-                  <a:srgbClr val="657184"/>
-                </a:solidFill>
-                <a:latin typeface="Aptos"/>
-                <a:ea typeface="Aptos"/>
-                <a:cs typeface="Aptos"/>
-              </a:rPr>
-              <a:t>ван</a:t>
-            </a:r>
-            <a:r>
-              <a:rPr sz="1575" b="0">
-                <a:solidFill>
-                  <a:srgbClr val="657184"/>
-                </a:solidFill>
-                <a:latin typeface="Aptos"/>
-                <a:ea typeface="Aptos"/>
-                <a:cs typeface="Aptos"/>
-              </a:rPr>
-              <a:t> </a:t>
-            </a:r>
-            <a:r>
-              <a:rPr sz="1575" b="0">
-                <a:solidFill>
-                  <a:srgbClr val="657184"/>
-                </a:solidFill>
-                <a:latin typeface="Aptos"/>
-                <a:ea typeface="Aptos"/>
-                <a:cs typeface="Aptos"/>
-              </a:rPr>
-              <a:t>контролисаног</a:t>
-            </a:r>
-            <a:r>
-              <a:rPr sz="1575" b="0">
-                <a:solidFill>
-                  <a:srgbClr val="657184"/>
-                </a:solidFill>
-                <a:latin typeface="Aptos"/>
-                <a:ea typeface="Aptos"/>
-                <a:cs typeface="Aptos"/>
-              </a:rPr>
-              <a:t> </a:t>
-            </a:r>
-            <a:r>
-              <a:rPr sz="1575" b="0">
-                <a:solidFill>
-                  <a:srgbClr val="657184"/>
-                </a:solidFill>
-                <a:latin typeface="Aptos"/>
-                <a:ea typeface="Aptos"/>
-                <a:cs typeface="Aptos"/>
-              </a:rPr>
-              <a:t>окружења</a:t>
-            </a:r>
-            <a:r>
-              <a:rPr sz="1575" b="0">
-                <a:solidFill>
-                  <a:srgbClr val="657184"/>
-                </a:solidFill>
-                <a:latin typeface="Aptos"/>
-                <a:ea typeface="Aptos"/>
-                <a:cs typeface="Aptos"/>
-              </a:rPr>
-              <a:t>.</a:t>
+              <a:t>Правила присуства, академског интегритета и контролисаног тестирања примењују се током целог семестра.</a:t>
             </a:r>
           </a:p>
         </p:txBody>
@@ -3445,7 +3238,7 @@
             </a:avLst>
           </a:prstGeom>
           <a:solidFill xmlns:a="http://schemas.openxmlformats.org/drawingml/2006/main">
-            <a:srgbClr val="EEF3FF"/>
+            <a:srgbClr val="F7EFF1"/>
           </a:solidFill>
           <a:ln xmlns:a="http://schemas.openxmlformats.org/drawingml/2006/main" w="9525">
             <a:solidFill>
@@ -3511,7 +3304,7 @@
             <a:r>
               <a:rPr sz="1275" b="1">
                 <a:solidFill>
-                  <a:srgbClr val="2F5EF5"/>
+                  <a:srgbClr val="7A2636"/>
                 </a:solidFill>
                 <a:latin typeface="Aptos"/>
                 <a:ea typeface="Aptos"/>
@@ -4117,11 +3910,11 @@
             </a:avLst>
           </a:prstGeom>
           <a:solidFill xmlns:a="http://schemas.openxmlformats.org/drawingml/2006/main">
-            <a:srgbClr val="EEF3FF"/>
+            <a:srgbClr val="F7EFF1"/>
           </a:solidFill>
           <a:ln xmlns:a="http://schemas.openxmlformats.org/drawingml/2006/main" w="8573">
             <a:solidFill>
-              <a:srgbClr val="CAD7F2"/>
+              <a:srgbClr val="DBC7CC"/>
             </a:solidFill>
             <a:prstDash val="solid"/>
           </a:ln>
@@ -4152,7 +3945,7 @@
             </a:avLst>
           </a:prstGeom>
           <a:solidFill xmlns:a="http://schemas.openxmlformats.org/drawingml/2006/main">
-            <a:srgbClr val="2F5EF5"/>
+            <a:srgbClr val="7A2636"/>
           </a:solidFill>
           <a:ln xmlns:a="http://schemas.openxmlformats.org/drawingml/2006/main" w="0">
             <a:noFill/>
@@ -4193,6 +3986,7 @@
           <a:lstStyle xmlns:a="http://schemas.openxmlformats.org/drawingml/2006/main"/>
           <a:p xmlns:a="http://schemas.openxmlformats.org/drawingml/2006/main">
             <a:pPr>
+              <a:buNone/>
               <a:defRPr sz="1200" b="1">
                 <a:solidFill>
                   <a:srgbClr val="2F5EF5"/>
@@ -4205,7 +3999,7 @@
             <a:r>
               <a:rPr sz="1200" b="1">
                 <a:solidFill>
-                  <a:srgbClr val="2F5EF5"/>
+                  <a:srgbClr val="7A2636"/>
                 </a:solidFill>
                 <a:latin typeface="Aptos"/>
                 <a:ea typeface="Aptos"/>
@@ -4250,6 +4044,7 @@
           <a:lstStyle xmlns:a="http://schemas.openxmlformats.org/drawingml/2006/main"/>
           <a:p xmlns:a="http://schemas.openxmlformats.org/drawingml/2006/main">
             <a:pPr>
+              <a:buNone/>
               <a:defRPr sz="1388" b="1">
                 <a:solidFill>
                   <a:srgbClr val="1B2432"/>
@@ -4331,7 +4126,7 @@
         </p:spPr>
         <p:txBody>
           <a:bodyPr xmlns:a="http://schemas.openxmlformats.org/drawingml/2006/main" wrap="square" lIns="0" tIns="0" rIns="0" bIns="0" anchor="t">
-            <a:normAutofit/>
+            <a:normAutofit fontScale="100000"/>
           </a:bodyPr>
           <a:lstStyle xmlns:a="http://schemas.openxmlformats.org/drawingml/2006/main"/>
           <a:p xmlns:a="http://schemas.openxmlformats.org/drawingml/2006/main">
@@ -4352,7 +4147,7 @@
             <a:r>
               <a:rPr sz="825" b="0">
                 <a:solidFill>
-                  <a:srgbClr val="657184"/>
+                  <a:srgbClr val="5E6B7D"/>
                 </a:solidFill>
                 <a:latin typeface="Aptos"/>
                 <a:ea typeface="Aptos"/>
@@ -4385,10 +4180,12 @@
           <a:prstGeom xmlns:a="http://schemas.openxmlformats.org/drawingml/2006/main" prst="line">
             <a:avLst/>
           </a:prstGeom>
-          <a:noFill xmlns:a="http://schemas.openxmlformats.org/drawingml/2006/main"/>
-          <a:ln xmlns:a="http://schemas.openxmlformats.org/drawingml/2006/main" w="9525">
+          <a:solidFill xmlns:a="http://schemas.openxmlformats.org/drawingml/2006/main">
+            <a:srgbClr val="8D5560"/>
+          </a:solidFill>
+          <a:ln xmlns:a="http://schemas.openxmlformats.org/drawingml/2006/main" w="7144">
             <a:solidFill>
-              <a:srgbClr val="748092"/>
+              <a:srgbClr val="8D5560"/>
             </a:solidFill>
             <a:prstDash val="solid"/>
           </a:ln>
@@ -4484,7 +4281,7 @@
         </p:spPr>
         <p:txBody>
           <a:bodyPr xmlns:a="http://schemas.openxmlformats.org/drawingml/2006/main" wrap="square" lIns="0" tIns="0" rIns="0" bIns="0" anchor="t">
-            <a:normAutofit/>
+            <a:normAutofit fontScale="100000"/>
           </a:bodyPr>
           <a:lstStyle xmlns:a="http://schemas.openxmlformats.org/drawingml/2006/main"/>
           <a:p xmlns:a="http://schemas.openxmlformats.org/drawingml/2006/main">
@@ -4511,7 +4308,7 @@
                 <a:ea typeface="Aptos Display"/>
                 <a:cs typeface="Aptos Display"/>
               </a:rPr>
-              <a:t>Прелазна правила зависе од признатих обавеза</a:t>
+              <a:t>Прелазна правила</a:t>
             </a:r>
           </a:p>
         </p:txBody>
@@ -4545,7 +4342,7 @@
         </p:spPr>
         <p:txBody>
           <a:bodyPr xmlns:a="http://schemas.openxmlformats.org/drawingml/2006/main" wrap="square" lIns="0" tIns="0" rIns="0" bIns="0" anchor="t">
-            <a:normAutofit/>
+            <a:normAutofit fontScale="100000"/>
           </a:bodyPr>
           <a:lstStyle xmlns:a="http://schemas.openxmlformats.org/drawingml/2006/main"/>
           <a:p xmlns:a="http://schemas.openxmlformats.org/drawingml/2006/main">
@@ -4572,7 +4369,7 @@
                 <a:ea typeface="Aptos"/>
                 <a:cs typeface="Aptos"/>
               </a:rPr>
-              <a:t>За раније генерације примењује се актуелни режим, уз конкретна признавања која студент већ има.</a:t>
+              <a:t>Раније генерације примењују актуелни режим полагања уз признавање претходно испуњених обавеза.</a:t>
             </a:r>
           </a:p>
         </p:txBody>
@@ -4887,7 +4684,7 @@
             </a:avLst>
           </a:prstGeom>
           <a:solidFill xmlns:a="http://schemas.openxmlformats.org/drawingml/2006/main">
-            <a:srgbClr val="EEF3FF"/>
+            <a:srgbClr val="F7EFF1"/>
           </a:solidFill>
           <a:ln xmlns:a="http://schemas.openxmlformats.org/drawingml/2006/main" w="9525">
             <a:solidFill>
@@ -4932,7 +4729,7 @@
         </p:spPr>
         <p:txBody>
           <a:bodyPr xmlns:a="http://schemas.openxmlformats.org/drawingml/2006/main" wrap="square" lIns="0" tIns="0" rIns="0" bIns="0" anchor="ctr">
-            <a:normAutofit/>
+            <a:normAutofit fontScale="100000"/>
           </a:bodyPr>
           <a:lstStyle xmlns:a="http://schemas.openxmlformats.org/drawingml/2006/main"/>
           <a:p xmlns:a="http://schemas.openxmlformats.org/drawingml/2006/main">
@@ -4953,7 +4750,7 @@
             <a:r>
               <a:rPr sz="1275" b="1">
                 <a:solidFill>
-                  <a:srgbClr val="2F5EF5"/>
+                  <a:srgbClr val="7A2636"/>
                 </a:solidFill>
                 <a:latin typeface="Aptos"/>
                 <a:ea typeface="Aptos"/>
@@ -5409,7 +5206,7 @@
         </p:spPr>
         <p:txBody>
           <a:bodyPr xmlns:a="http://schemas.openxmlformats.org/drawingml/2006/main" wrap="square" lIns="0" tIns="0" rIns="0" bIns="0" anchor="t">
-            <a:normAutofit/>
+            <a:normAutofit fontScale="100000"/>
           </a:bodyPr>
           <a:lstStyle xmlns:a="http://schemas.openxmlformats.org/drawingml/2006/main"/>
           <a:p xmlns:a="http://schemas.openxmlformats.org/drawingml/2006/main">
@@ -5430,7 +5227,7 @@
             <a:r>
               <a:rPr sz="825" b="0">
                 <a:solidFill>
-                  <a:srgbClr val="657184"/>
+                  <a:srgbClr val="5E6B7D"/>
                 </a:solidFill>
                 <a:latin typeface="Aptos"/>
                 <a:ea typeface="Aptos"/>
@@ -5463,10 +5260,12 @@
           <a:prstGeom xmlns:a="http://schemas.openxmlformats.org/drawingml/2006/main" prst="line">
             <a:avLst/>
           </a:prstGeom>
-          <a:noFill xmlns:a="http://schemas.openxmlformats.org/drawingml/2006/main"/>
-          <a:ln xmlns:a="http://schemas.openxmlformats.org/drawingml/2006/main" w="9525">
+          <a:solidFill xmlns:a="http://schemas.openxmlformats.org/drawingml/2006/main">
+            <a:srgbClr val="8D5560"/>
+          </a:solidFill>
+          <a:ln xmlns:a="http://schemas.openxmlformats.org/drawingml/2006/main" w="7144">
             <a:solidFill>
-              <a:srgbClr val="748092"/>
+              <a:srgbClr val="8D5560"/>
             </a:solidFill>
             <a:prstDash val="solid"/>
           </a:ln>
@@ -5562,7 +5361,7 @@
         </p:spPr>
         <p:txBody>
           <a:bodyPr xmlns:a="http://schemas.openxmlformats.org/drawingml/2006/main" wrap="square" lIns="0" tIns="0" rIns="0" bIns="0" anchor="t">
-            <a:normAutofit/>
+            <a:normAutofit fontScale="100000"/>
           </a:bodyPr>
           <a:lstStyle xmlns:a="http://schemas.openxmlformats.org/drawingml/2006/main"/>
           <a:p xmlns:a="http://schemas.openxmlformats.org/drawingml/2006/main">
@@ -5589,7 +5388,7 @@
                 <a:ea typeface="Aptos Display"/>
                 <a:cs typeface="Aptos Display"/>
               </a:rPr>
-              <a:t>Како користити практикум</a:t>
+              <a:t>Рад са практикумом</a:t>
             </a:r>
           </a:p>
         </p:txBody>
@@ -5623,7 +5422,7 @@
         </p:spPr>
         <p:txBody>
           <a:bodyPr xmlns:a="http://schemas.openxmlformats.org/drawingml/2006/main" wrap="square" lIns="0" tIns="0" rIns="0" bIns="0" anchor="t">
-            <a:normAutofit/>
+            <a:normAutofit fontScale="100000"/>
           </a:bodyPr>
           <a:lstStyle xmlns:a="http://schemas.openxmlformats.org/drawingml/2006/main"/>
           <a:p xmlns:a="http://schemas.openxmlformats.org/drawingml/2006/main">
@@ -5650,7 +5449,7 @@
                 <a:ea typeface="Aptos"/>
                 <a:cs typeface="Aptos"/>
               </a:rPr>
-              <a:t>Циљ није памћење једног примера, већ способност да се принцип пренесе на додељену пројектну целину.</a:t>
+              <a:t>Практикум служи за разумевање принципа и њихову примену на додељену пројектну целину.</a:t>
             </a:r>
           </a:p>
         </p:txBody>
@@ -5746,7 +5545,7 @@
             <a:r>
               <a:rPr sz="1238" b="1">
                 <a:solidFill>
-                  <a:srgbClr val="2F5EF5"/>
+                  <a:srgbClr val="7A2636"/>
                 </a:solidFill>
                 <a:latin typeface="Aptos"/>
                 <a:ea typeface="Aptos"/>
@@ -5847,7 +5646,7 @@
         </p:spPr>
         <p:txBody>
           <a:bodyPr xmlns:a="http://schemas.openxmlformats.org/drawingml/2006/main" wrap="square" lIns="0" tIns="0" rIns="0" bIns="0" anchor="ctr">
-            <a:normAutofit fontScale="83333"/>
+            <a:normAutofit fontScale="96109"/>
           </a:bodyPr>
           <a:lstStyle xmlns:a="http://schemas.openxmlformats.org/drawingml/2006/main"/>
           <a:p xmlns:a="http://schemas.openxmlformats.org/drawingml/2006/main">
@@ -5874,7 +5673,7 @@
                 <a:ea typeface="Aptos"/>
                 <a:cs typeface="Aptos"/>
               </a:rPr>
-              <a:t>прочитај тему и издвој претпоставке</a:t>
+              <a:t>анализа теме и претпоставки</a:t>
             </a:r>
           </a:p>
         </p:txBody>
@@ -5904,7 +5703,7 @@
             </a:avLst>
           </a:prstGeom>
           <a:solidFill xmlns:a="http://schemas.openxmlformats.org/drawingml/2006/main">
-            <a:srgbClr val="EEF3FF"/>
+            <a:srgbClr val="F7EFF1"/>
           </a:solidFill>
           <a:ln xmlns:a="http://schemas.openxmlformats.org/drawingml/2006/main" w="9525">
             <a:solidFill>
@@ -5970,7 +5769,7 @@
             <a:r>
               <a:rPr sz="1238" b="1">
                 <a:solidFill>
-                  <a:srgbClr val="2F5EF5"/>
+                  <a:srgbClr val="7A2636"/>
                 </a:solidFill>
                 <a:latin typeface="Aptos"/>
                 <a:ea typeface="Aptos"/>
@@ -6071,7 +5870,7 @@
         </p:spPr>
         <p:txBody>
           <a:bodyPr xmlns:a="http://schemas.openxmlformats.org/drawingml/2006/main" wrap="square" lIns="0" tIns="0" rIns="0" bIns="0" anchor="ctr">
-            <a:normAutofit fontScale="97044"/>
+            <a:normAutofit fontScale="90321"/>
           </a:bodyPr>
           <a:lstStyle xmlns:a="http://schemas.openxmlformats.org/drawingml/2006/main"/>
           <a:p xmlns:a="http://schemas.openxmlformats.org/drawingml/2006/main">
@@ -6098,7 +5897,7 @@
                 <a:ea typeface="Aptos"/>
                 <a:cs typeface="Aptos"/>
               </a:rPr>
-              <a:t>повежи појам са последицом</a:t>
+              <a:t>повезивање појма и последице</a:t>
             </a:r>
           </a:p>
         </p:txBody>
@@ -6128,7 +5927,7 @@
             </a:avLst>
           </a:prstGeom>
           <a:solidFill xmlns:a="http://schemas.openxmlformats.org/drawingml/2006/main">
-            <a:srgbClr val="F5F0FF"/>
+            <a:srgbClr val="F7F4F5"/>
           </a:solidFill>
           <a:ln xmlns:a="http://schemas.openxmlformats.org/drawingml/2006/main" w="9525">
             <a:solidFill>
@@ -6194,7 +5993,7 @@
             <a:r>
               <a:rPr sz="1238" b="1">
                 <a:solidFill>
-                  <a:srgbClr val="7651D4"/>
+                  <a:srgbClr val="7A2636"/>
                 </a:solidFill>
                 <a:latin typeface="Aptos"/>
                 <a:ea typeface="Aptos"/>
@@ -6295,7 +6094,7 @@
         </p:spPr>
         <p:txBody>
           <a:bodyPr xmlns:a="http://schemas.openxmlformats.org/drawingml/2006/main" wrap="square" lIns="0" tIns="0" rIns="0" bIns="0" anchor="ctr">
-            <a:normAutofit fontScale="95797"/>
+            <a:normAutofit fontScale="92179"/>
           </a:bodyPr>
           <a:lstStyle xmlns:a="http://schemas.openxmlformats.org/drawingml/2006/main"/>
           <a:p xmlns:a="http://schemas.openxmlformats.org/drawingml/2006/main">
@@ -6322,7 +6121,7 @@
                 <a:ea typeface="Aptos"/>
                 <a:cs typeface="Aptos"/>
               </a:rPr>
-              <a:t>примени принцип на пројекат</a:t>
+              <a:t>примена принципа на пројекат</a:t>
             </a:r>
           </a:p>
         </p:txBody>
@@ -6546,14 +6345,14 @@
                 <a:ea typeface="Aptos"/>
                 <a:cs typeface="Aptos"/>
               </a:rPr>
-              <a:t>покажи контролу и доказ</a:t>
+              <a:t>приказ контроле и доказа</a:t>
             </a:r>
           </a:p>
         </p:txBody>
       </p:sp>
       <p:cxnSp>
         <p:nvCxnSpPr>
-          <p:cNvPr id="193" name="Straight Arrow Connector 96"/>
+          <p:cNvPr id="289" name="Straight Arrow Connector 96"/>
           <p:cNvCxnSpPr>
             <a:stCxn xmlns:a="http://schemas.openxmlformats.org/drawingml/2006/main" id="6" idx="3"/>
             <a:endCxn xmlns:a="http://schemas.openxmlformats.org/drawingml/2006/main" id="10" idx="1"/>
@@ -6579,7 +6378,7 @@
       </p:cxnSp>
       <p:cxnSp>
         <p:nvCxnSpPr>
-          <p:cNvPr id="194" name="Straight Arrow Connector 97"/>
+          <p:cNvPr id="290" name="Straight Arrow Connector 97"/>
           <p:cNvCxnSpPr>
             <a:stCxn xmlns:a="http://schemas.openxmlformats.org/drawingml/2006/main" id="10" idx="3"/>
             <a:endCxn xmlns:a="http://schemas.openxmlformats.org/drawingml/2006/main" id="14" idx="1"/>
@@ -6605,7 +6404,7 @@
       </p:cxnSp>
       <p:cxnSp>
         <p:nvCxnSpPr>
-          <p:cNvPr id="195" name="Straight Arrow Connector 98"/>
+          <p:cNvPr id="291" name="Straight Arrow Connector 98"/>
           <p:cNvCxnSpPr>
             <a:stCxn xmlns:a="http://schemas.openxmlformats.org/drawingml/2006/main" id="14" idx="3"/>
             <a:endCxn xmlns:a="http://schemas.openxmlformats.org/drawingml/2006/main" id="18" idx="1"/>
@@ -6754,7 +6553,7 @@
         </p:spPr>
         <p:txBody>
           <a:bodyPr xmlns:a="http://schemas.openxmlformats.org/drawingml/2006/main" wrap="square" lIns="0" tIns="0" rIns="0" bIns="0" anchor="t">
-            <a:normAutofit/>
+            <a:normAutofit fontScale="100000"/>
           </a:bodyPr>
           <a:lstStyle xmlns:a="http://schemas.openxmlformats.org/drawingml/2006/main"/>
           <a:p xmlns:a="http://schemas.openxmlformats.org/drawingml/2006/main">
@@ -6781,7 +6580,7 @@
                 <a:ea typeface="Aptos"/>
                 <a:cs typeface="Aptos"/>
               </a:rPr>
-              <a:t>Проблем који решавамо · изабрана контрола · њено ограничење · тест, audit траг или демонстрација која доказује понашање.</a:t>
+              <a:t>Проблем који решавамо, изабрана контрола, њено ограничење, тест, ревизиони траг или демонстрација која доказује понашање.</a:t>
             </a:r>
           </a:p>
         </p:txBody>
@@ -6844,7 +6643,7 @@
         </p:spPr>
         <p:txBody>
           <a:bodyPr xmlns:a="http://schemas.openxmlformats.org/drawingml/2006/main" wrap="square" lIns="0" tIns="0" rIns="0" bIns="0" anchor="t">
-            <a:normAutofit/>
+            <a:normAutofit fontScale="100000"/>
           </a:bodyPr>
           <a:lstStyle xmlns:a="http://schemas.openxmlformats.org/drawingml/2006/main"/>
           <a:p xmlns:a="http://schemas.openxmlformats.org/drawingml/2006/main">
@@ -6865,7 +6664,7 @@
             <a:r>
               <a:rPr sz="825" b="0">
                 <a:solidFill>
-                  <a:srgbClr val="657184"/>
+                  <a:srgbClr val="5E6B7D"/>
                 </a:solidFill>
                 <a:latin typeface="Aptos"/>
                 <a:ea typeface="Aptos"/>
@@ -6898,10 +6697,12 @@
           <a:prstGeom xmlns:a="http://schemas.openxmlformats.org/drawingml/2006/main" prst="line">
             <a:avLst/>
           </a:prstGeom>
-          <a:noFill xmlns:a="http://schemas.openxmlformats.org/drawingml/2006/main"/>
-          <a:ln xmlns:a="http://schemas.openxmlformats.org/drawingml/2006/main" w="9525">
+          <a:solidFill xmlns:a="http://schemas.openxmlformats.org/drawingml/2006/main">
+            <a:srgbClr val="8D5560"/>
+          </a:solidFill>
+          <a:ln xmlns:a="http://schemas.openxmlformats.org/drawingml/2006/main" w="7144">
             <a:solidFill>
-              <a:srgbClr val="748092"/>
+              <a:srgbClr val="8D5560"/>
             </a:solidFill>
             <a:prstDash val="solid"/>
           </a:ln>
@@ -7058,7 +6859,7 @@
         </p:spPr>
         <p:txBody>
           <a:bodyPr xmlns:a="http://schemas.openxmlformats.org/drawingml/2006/main" wrap="square" lIns="0" tIns="0" rIns="0" bIns="0" anchor="t">
-            <a:normAutofit/>
+            <a:normAutofit fontScale="100000"/>
           </a:bodyPr>
           <a:lstStyle xmlns:a="http://schemas.openxmlformats.org/drawingml/2006/main"/>
           <a:p xmlns:a="http://schemas.openxmlformats.org/drawingml/2006/main">
@@ -7085,7 +6886,7 @@
                 <a:ea typeface="Aptos"/>
                 <a:cs typeface="Aptos"/>
               </a:rPr>
-              <a:t>На крају предмета студент повезује безбедносни проблем са контролом и проверљивим доказом.</a:t>
+              <a:t>Студент повезује безбедносни проблем са одговарајућом контролом и проверљивим доказом њеног рада.</a:t>
             </a:r>
           </a:p>
         </p:txBody>
@@ -7115,7 +6916,7 @@
             </a:avLst>
           </a:prstGeom>
           <a:solidFill xmlns:a="http://schemas.openxmlformats.org/drawingml/2006/main">
-            <a:srgbClr val="EEF3FF"/>
+            <a:srgbClr val="F7EFF1"/>
           </a:solidFill>
           <a:ln xmlns:a="http://schemas.openxmlformats.org/drawingml/2006/main" w="9525">
             <a:solidFill>
@@ -7181,7 +6982,7 @@
             <a:r>
               <a:rPr sz="1275" b="1">
                 <a:solidFill>
-                  <a:srgbClr val="2F5EF5"/>
+                  <a:srgbClr val="7A2636"/>
                 </a:solidFill>
                 <a:latin typeface="Aptos"/>
                 <a:ea typeface="Aptos"/>
@@ -7339,7 +7140,7 @@
             </a:avLst>
           </a:prstGeom>
           <a:solidFill xmlns:a="http://schemas.openxmlformats.org/drawingml/2006/main">
-            <a:srgbClr val="F5F0FF"/>
+            <a:srgbClr val="F7F4F5"/>
           </a:solidFill>
           <a:ln xmlns:a="http://schemas.openxmlformats.org/drawingml/2006/main" w="9525">
             <a:solidFill>
@@ -7405,7 +7206,7 @@
             <a:r>
               <a:rPr sz="1275" b="1">
                 <a:solidFill>
-                  <a:srgbClr val="7651D4"/>
+                  <a:srgbClr val="7A2636"/>
                 </a:solidFill>
                 <a:latin typeface="Aptos"/>
                 <a:ea typeface="Aptos"/>
@@ -7669,7 +7470,7 @@
         </p:spPr>
         <p:txBody>
           <a:bodyPr xmlns:a="http://schemas.openxmlformats.org/drawingml/2006/main" wrap="square" lIns="0" tIns="0" rIns="0" bIns="0" anchor="ctr">
-            <a:normAutofit/>
+            <a:normAutofit fontScale="100000"/>
           </a:bodyPr>
           <a:lstStyle xmlns:a="http://schemas.openxmlformats.org/drawingml/2006/main"/>
           <a:p xmlns:a="http://schemas.openxmlformats.org/drawingml/2006/main">
@@ -7696,7 +7497,7 @@
                 <a:ea typeface="Aptos"/>
                 <a:cs typeface="Aptos"/>
               </a:rPr>
-              <a:t>Тест и audit траг</a:t>
+              <a:t>Тест и ревизиони траг</a:t>
             </a:r>
           </a:p>
         </p:txBody>
@@ -7820,7 +7621,7 @@
         </p:spPr>
         <p:txBody>
           <a:bodyPr xmlns:a="http://schemas.openxmlformats.org/drawingml/2006/main" wrap="square" lIns="0" tIns="0" rIns="0" bIns="0" anchor="t">
-            <a:normAutofit/>
+            <a:normAutofit fontScale="100000"/>
           </a:bodyPr>
           <a:lstStyle xmlns:a="http://schemas.openxmlformats.org/drawingml/2006/main"/>
           <a:p xmlns:a="http://schemas.openxmlformats.org/drawingml/2006/main">
@@ -7841,7 +7642,7 @@
             <a:r>
               <a:rPr sz="825" b="0">
                 <a:solidFill>
-                  <a:srgbClr val="657184"/>
+                  <a:srgbClr val="5E6B7D"/>
                 </a:solidFill>
                 <a:latin typeface="Aptos"/>
                 <a:ea typeface="Aptos"/>
@@ -7874,10 +7675,12 @@
           <a:prstGeom xmlns:a="http://schemas.openxmlformats.org/drawingml/2006/main" prst="line">
             <a:avLst/>
           </a:prstGeom>
-          <a:noFill xmlns:a="http://schemas.openxmlformats.org/drawingml/2006/main"/>
-          <a:ln xmlns:a="http://schemas.openxmlformats.org/drawingml/2006/main" w="9525">
+          <a:solidFill xmlns:a="http://schemas.openxmlformats.org/drawingml/2006/main">
+            <a:srgbClr val="8D5560"/>
+          </a:solidFill>
+          <a:ln xmlns:a="http://schemas.openxmlformats.org/drawingml/2006/main" w="7144">
             <a:solidFill>
-              <a:srgbClr val="748092"/>
+              <a:srgbClr val="8D5560"/>
             </a:solidFill>
             <a:prstDash val="solid"/>
           </a:ln>
@@ -7973,7 +7776,7 @@
         </p:spPr>
         <p:txBody>
           <a:bodyPr xmlns:a="http://schemas.openxmlformats.org/drawingml/2006/main" wrap="square" lIns="0" tIns="0" rIns="0" bIns="0" anchor="t">
-            <a:normAutofit/>
+            <a:normAutofit fontScale="100000"/>
           </a:bodyPr>
           <a:lstStyle xmlns:a="http://schemas.openxmlformats.org/drawingml/2006/main"/>
           <a:p xmlns:a="http://schemas.openxmlformats.org/drawingml/2006/main">
@@ -8000,7 +7803,7 @@
                 <a:ea typeface="Aptos Display"/>
                 <a:cs typeface="Aptos Display"/>
               </a:rPr>
-              <a:t>Шта се очекује од редовног пројекта</a:t>
+              <a:t>Захтеви редовног пројекта</a:t>
             </a:r>
           </a:p>
         </p:txBody>
@@ -8157,7 +7960,7 @@
             <a:r>
               <a:rPr sz="1238" b="1">
                 <a:solidFill>
-                  <a:srgbClr val="2F5EF5"/>
+                  <a:srgbClr val="7A2636"/>
                 </a:solidFill>
                 <a:latin typeface="Aptos"/>
                 <a:ea typeface="Aptos"/>
@@ -8315,7 +8118,7 @@
             </a:avLst>
           </a:prstGeom>
           <a:solidFill xmlns:a="http://schemas.openxmlformats.org/drawingml/2006/main">
-            <a:srgbClr val="EEF3FF"/>
+            <a:srgbClr val="F7EFF1"/>
           </a:solidFill>
           <a:ln xmlns:a="http://schemas.openxmlformats.org/drawingml/2006/main" w="9525">
             <a:solidFill>
@@ -8381,7 +8184,7 @@
             <a:r>
               <a:rPr sz="1238" b="1">
                 <a:solidFill>
-                  <a:srgbClr val="2F5EF5"/>
+                  <a:srgbClr val="7A2636"/>
                 </a:solidFill>
                 <a:latin typeface="Aptos"/>
                 <a:ea typeface="Aptos"/>
@@ -8539,7 +8342,7 @@
             </a:avLst>
           </a:prstGeom>
           <a:solidFill xmlns:a="http://schemas.openxmlformats.org/drawingml/2006/main">
-            <a:srgbClr val="F5F0FF"/>
+            <a:srgbClr val="F7F4F5"/>
           </a:solidFill>
           <a:ln xmlns:a="http://schemas.openxmlformats.org/drawingml/2006/main" w="9525">
             <a:solidFill>
@@ -8605,7 +8408,7 @@
             <a:r>
               <a:rPr sz="1238" b="1">
                 <a:solidFill>
-                  <a:srgbClr val="7651D4"/>
+                  <a:srgbClr val="7A2636"/>
                 </a:solidFill>
                 <a:latin typeface="Aptos"/>
                 <a:ea typeface="Aptos"/>
@@ -9188,7 +8991,7 @@
       </p:sp>
       <p:cxnSp>
         <p:nvCxnSpPr>
-          <p:cNvPr id="234" name="Straight Arrow Connector 113"/>
+          <p:cNvPr id="350" name="Straight Arrow Connector 113"/>
           <p:cNvCxnSpPr>
             <a:stCxn xmlns:a="http://schemas.openxmlformats.org/drawingml/2006/main" id="6" idx="3"/>
             <a:endCxn xmlns:a="http://schemas.openxmlformats.org/drawingml/2006/main" id="10" idx="1"/>
@@ -9214,7 +9017,7 @@
       </p:cxnSp>
       <p:cxnSp>
         <p:nvCxnSpPr>
-          <p:cNvPr id="235" name="Straight Arrow Connector 114"/>
+          <p:cNvPr id="351" name="Straight Arrow Connector 114"/>
           <p:cNvCxnSpPr>
             <a:stCxn xmlns:a="http://schemas.openxmlformats.org/drawingml/2006/main" id="10" idx="3"/>
             <a:endCxn xmlns:a="http://schemas.openxmlformats.org/drawingml/2006/main" id="14" idx="1"/>
@@ -9240,7 +9043,7 @@
       </p:cxnSp>
       <p:cxnSp>
         <p:nvCxnSpPr>
-          <p:cNvPr id="236" name="Straight Arrow Connector 115"/>
+          <p:cNvPr id="352" name="Straight Arrow Connector 115"/>
           <p:cNvCxnSpPr>
             <a:stCxn xmlns:a="http://schemas.openxmlformats.org/drawingml/2006/main" id="14" idx="3"/>
             <a:endCxn xmlns:a="http://schemas.openxmlformats.org/drawingml/2006/main" id="18" idx="1"/>
@@ -9266,7 +9069,7 @@
       </p:cxnSp>
       <p:cxnSp>
         <p:nvCxnSpPr>
-          <p:cNvPr id="237" name="Straight Arrow Connector 116"/>
+          <p:cNvPr id="353" name="Straight Arrow Connector 116"/>
           <p:cNvCxnSpPr>
             <a:stCxn xmlns:a="http://schemas.openxmlformats.org/drawingml/2006/main" id="18" idx="3"/>
             <a:endCxn xmlns:a="http://schemas.openxmlformats.org/drawingml/2006/main" id="22" idx="1"/>
@@ -9315,11 +9118,11 @@
             </a:avLst>
           </a:prstGeom>
           <a:solidFill xmlns:a="http://schemas.openxmlformats.org/drawingml/2006/main">
-            <a:srgbClr val="EEF3FF"/>
+            <a:srgbClr val="F7EFF1"/>
           </a:solidFill>
           <a:ln xmlns:a="http://schemas.openxmlformats.org/drawingml/2006/main" w="8573">
             <a:solidFill>
-              <a:srgbClr val="CAD7F2"/>
+              <a:srgbClr val="DBC7CC"/>
             </a:solidFill>
             <a:prstDash val="solid"/>
           </a:ln>
@@ -9350,7 +9153,7 @@
             </a:avLst>
           </a:prstGeom>
           <a:solidFill xmlns:a="http://schemas.openxmlformats.org/drawingml/2006/main">
-            <a:srgbClr val="2F5EF5"/>
+            <a:srgbClr val="7A2636"/>
           </a:solidFill>
           <a:ln xmlns:a="http://schemas.openxmlformats.org/drawingml/2006/main" w="0">
             <a:noFill/>
@@ -9391,6 +9194,7 @@
           <a:lstStyle xmlns:a="http://schemas.openxmlformats.org/drawingml/2006/main"/>
           <a:p xmlns:a="http://schemas.openxmlformats.org/drawingml/2006/main">
             <a:pPr>
+              <a:buNone/>
               <a:defRPr sz="1200" b="1">
                 <a:solidFill>
                   <a:srgbClr val="2F5EF5"/>
@@ -9403,7 +9207,7 @@
             <a:r>
               <a:rPr sz="1200" b="1">
                 <a:solidFill>
-                  <a:srgbClr val="2F5EF5"/>
+                  <a:srgbClr val="7A2636"/>
                 </a:solidFill>
                 <a:latin typeface="Aptos"/>
                 <a:ea typeface="Aptos"/>
@@ -9448,6 +9252,7 @@
           <a:lstStyle xmlns:a="http://schemas.openxmlformats.org/drawingml/2006/main"/>
           <a:p xmlns:a="http://schemas.openxmlformats.org/drawingml/2006/main">
             <a:pPr>
+              <a:buNone/>
               <a:defRPr sz="1388" b="1">
                 <a:solidFill>
                   <a:srgbClr val="1B2432"/>
@@ -9529,7 +9334,7 @@
         </p:spPr>
         <p:txBody>
           <a:bodyPr xmlns:a="http://schemas.openxmlformats.org/drawingml/2006/main" wrap="square" lIns="0" tIns="0" rIns="0" bIns="0" anchor="t">
-            <a:normAutofit/>
+            <a:normAutofit fontScale="100000"/>
           </a:bodyPr>
           <a:lstStyle xmlns:a="http://schemas.openxmlformats.org/drawingml/2006/main"/>
           <a:p xmlns:a="http://schemas.openxmlformats.org/drawingml/2006/main">
@@ -9550,7 +9355,7 @@
             <a:r>
               <a:rPr sz="825" b="0">
                 <a:solidFill>
-                  <a:srgbClr val="657184"/>
+                  <a:srgbClr val="5E6B7D"/>
                 </a:solidFill>
                 <a:latin typeface="Aptos"/>
                 <a:ea typeface="Aptos"/>
@@ -9583,10 +9388,12 @@
           <a:prstGeom xmlns:a="http://schemas.openxmlformats.org/drawingml/2006/main" prst="line">
             <a:avLst/>
           </a:prstGeom>
-          <a:noFill xmlns:a="http://schemas.openxmlformats.org/drawingml/2006/main"/>
-          <a:ln xmlns:a="http://schemas.openxmlformats.org/drawingml/2006/main" w="9525">
+          <a:solidFill xmlns:a="http://schemas.openxmlformats.org/drawingml/2006/main">
+            <a:srgbClr val="8D5560"/>
+          </a:solidFill>
+          <a:ln xmlns:a="http://schemas.openxmlformats.org/drawingml/2006/main" w="7144">
             <a:solidFill>
-              <a:srgbClr val="748092"/>
+              <a:srgbClr val="8D5560"/>
             </a:solidFill>
             <a:prstDash val="solid"/>
           </a:ln>
@@ -9743,7 +9550,7 @@
         </p:spPr>
         <p:txBody>
           <a:bodyPr xmlns:a="http://schemas.openxmlformats.org/drawingml/2006/main" wrap="square" lIns="0" tIns="0" rIns="0" bIns="0" anchor="t">
-            <a:normAutofit fontScale="95238"/>
+            <a:normAutofit fontScale="98331"/>
           </a:bodyPr>
           <a:lstStyle xmlns:a="http://schemas.openxmlformats.org/drawingml/2006/main"/>
           <a:p xmlns:a="http://schemas.openxmlformats.org/drawingml/2006/main">
@@ -9770,7 +9577,7 @@
                 <a:ea typeface="Aptos"/>
                 <a:cs typeface="Aptos"/>
               </a:rPr>
-              <a:t>Овај начин полагања намењен је практичном делу дипломског рада који је непосредно повезан са информационом безбедношћу.</a:t>
+              <a:t>Супер пројекат представља практични део дипломског рада непосредно повезан са информационом безбедношћу.</a:t>
             </a:r>
           </a:p>
         </p:txBody>
@@ -10024,7 +9831,7 @@
             </a:avLst>
           </a:prstGeom>
           <a:solidFill xmlns:a="http://schemas.openxmlformats.org/drawingml/2006/main">
-            <a:srgbClr val="EEF3FF"/>
+            <a:srgbClr val="F7EFF1"/>
           </a:solidFill>
           <a:ln xmlns:a="http://schemas.openxmlformats.org/drawingml/2006/main" w="9525">
             <a:solidFill>
@@ -10090,7 +9897,7 @@
             <a:r>
               <a:rPr sz="1275" b="1">
                 <a:solidFill>
-                  <a:srgbClr val="2F5EF5"/>
+                  <a:srgbClr val="7A2636"/>
                 </a:solidFill>
                 <a:latin typeface="Aptos"/>
                 <a:ea typeface="Aptos"/>
@@ -10505,7 +10312,7 @@
         </p:spPr>
         <p:txBody>
           <a:bodyPr xmlns:a="http://schemas.openxmlformats.org/drawingml/2006/main" wrap="square" lIns="0" tIns="0" rIns="0" bIns="0" anchor="t">
-            <a:normAutofit/>
+            <a:normAutofit fontScale="100000"/>
           </a:bodyPr>
           <a:lstStyle xmlns:a="http://schemas.openxmlformats.org/drawingml/2006/main"/>
           <a:p xmlns:a="http://schemas.openxmlformats.org/drawingml/2006/main">
@@ -10526,7 +10333,7 @@
             <a:r>
               <a:rPr sz="825" b="0">
                 <a:solidFill>
-                  <a:srgbClr val="657184"/>
+                  <a:srgbClr val="5E6B7D"/>
                 </a:solidFill>
                 <a:latin typeface="Aptos"/>
                 <a:ea typeface="Aptos"/>
@@ -10559,10 +10366,12 @@
           <a:prstGeom xmlns:a="http://schemas.openxmlformats.org/drawingml/2006/main" prst="line">
             <a:avLst/>
           </a:prstGeom>
-          <a:noFill xmlns:a="http://schemas.openxmlformats.org/drawingml/2006/main"/>
-          <a:ln xmlns:a="http://schemas.openxmlformats.org/drawingml/2006/main" w="9525">
+          <a:solidFill xmlns:a="http://schemas.openxmlformats.org/drawingml/2006/main">
+            <a:srgbClr val="8D5560"/>
+          </a:solidFill>
+          <a:ln xmlns:a="http://schemas.openxmlformats.org/drawingml/2006/main" w="7144">
             <a:solidFill>
-              <a:srgbClr val="748092"/>
+              <a:srgbClr val="8D5560"/>
             </a:solidFill>
             <a:prstDash val="solid"/>
           </a:ln>
@@ -10658,7 +10467,7 @@
         </p:spPr>
         <p:txBody>
           <a:bodyPr xmlns:a="http://schemas.openxmlformats.org/drawingml/2006/main" wrap="square" lIns="0" tIns="0" rIns="0" bIns="0" anchor="t">
-            <a:normAutofit/>
+            <a:normAutofit fontScale="100000"/>
           </a:bodyPr>
           <a:lstStyle xmlns:a="http://schemas.openxmlformats.org/drawingml/2006/main"/>
           <a:p xmlns:a="http://schemas.openxmlformats.org/drawingml/2006/main">
@@ -10685,7 +10494,7 @@
                 <a:ea typeface="Aptos Display"/>
                 <a:cs typeface="Aptos Display"/>
               </a:rPr>
-              <a:t>Шта се показује на контролним тачкама</a:t>
+              <a:t>Садржај контролних тачака</a:t>
             </a:r>
           </a:p>
         </p:txBody>
@@ -10719,7 +10528,7 @@
         </p:spPr>
         <p:txBody>
           <a:bodyPr xmlns:a="http://schemas.openxmlformats.org/drawingml/2006/main" wrap="square" lIns="0" tIns="0" rIns="0" bIns="0" anchor="t">
-            <a:normAutofit/>
+            <a:normAutofit fontScale="100000"/>
           </a:bodyPr>
           <a:lstStyle xmlns:a="http://schemas.openxmlformats.org/drawingml/2006/main"/>
           <a:p xmlns:a="http://schemas.openxmlformats.org/drawingml/2006/main">
@@ -10746,7 +10555,7 @@
                 <a:ea typeface="Aptos"/>
                 <a:cs typeface="Aptos"/>
               </a:rPr>
-              <a:t>Контролна тачка не тражи савршен систем, већ видљив напредак и доказ да тим разуме границу коју гради.</a:t>
+              <a:t>Свака контролна тачка утврђује конкретан обим имплементације, тестова и доказа који тим представља.</a:t>
             </a:r>
           </a:p>
         </p:txBody>
@@ -10776,7 +10585,7 @@
             </a:avLst>
           </a:prstGeom>
           <a:solidFill xmlns:a="http://schemas.openxmlformats.org/drawingml/2006/main">
-            <a:srgbClr val="EEF3FF"/>
+            <a:srgbClr val="F7EFF1"/>
           </a:solidFill>
           <a:ln xmlns:a="http://schemas.openxmlformats.org/drawingml/2006/main" w="9525">
             <a:solidFill>
@@ -10842,7 +10651,7 @@
             <a:r>
               <a:rPr sz="1275" b="1">
                 <a:solidFill>
-                  <a:srgbClr val="2F5EF5"/>
+                  <a:srgbClr val="7A2636"/>
                 </a:solidFill>
                 <a:latin typeface="Aptos"/>
                 <a:ea typeface="Aptos"/>
@@ -11000,7 +10809,7 @@
             </a:avLst>
           </a:prstGeom>
           <a:solidFill xmlns:a="http://schemas.openxmlformats.org/drawingml/2006/main">
-            <a:srgbClr val="F5F0FF"/>
+            <a:srgbClr val="F7F4F5"/>
           </a:solidFill>
           <a:ln xmlns:a="http://schemas.openxmlformats.org/drawingml/2006/main" w="9525">
             <a:solidFill>
@@ -11066,7 +10875,7 @@
             <a:r>
               <a:rPr sz="1275" b="1">
                 <a:solidFill>
-                  <a:srgbClr val="7651D4"/>
+                  <a:srgbClr val="7A2636"/>
                 </a:solidFill>
                 <a:latin typeface="Aptos"/>
                 <a:ea typeface="Aptos"/>
@@ -11705,7 +11514,7 @@
         </p:spPr>
         <p:txBody>
           <a:bodyPr xmlns:a="http://schemas.openxmlformats.org/drawingml/2006/main" wrap="square" lIns="0" tIns="0" rIns="0" bIns="0" anchor="t">
-            <a:normAutofit/>
+            <a:normAutofit fontScale="100000"/>
           </a:bodyPr>
           <a:lstStyle xmlns:a="http://schemas.openxmlformats.org/drawingml/2006/main"/>
           <a:p xmlns:a="http://schemas.openxmlformats.org/drawingml/2006/main">
@@ -11726,7 +11535,7 @@
             <a:r>
               <a:rPr sz="825" b="0">
                 <a:solidFill>
-                  <a:srgbClr val="657184"/>
+                  <a:srgbClr val="5E6B7D"/>
                 </a:solidFill>
                 <a:latin typeface="Aptos"/>
                 <a:ea typeface="Aptos"/>
@@ -11759,10 +11568,12 @@
           <a:prstGeom xmlns:a="http://schemas.openxmlformats.org/drawingml/2006/main" prst="line">
             <a:avLst/>
           </a:prstGeom>
-          <a:noFill xmlns:a="http://schemas.openxmlformats.org/drawingml/2006/main"/>
-          <a:ln xmlns:a="http://schemas.openxmlformats.org/drawingml/2006/main" w="9525">
+          <a:solidFill xmlns:a="http://schemas.openxmlformats.org/drawingml/2006/main">
+            <a:srgbClr val="8D5560"/>
+          </a:solidFill>
+          <a:ln xmlns:a="http://schemas.openxmlformats.org/drawingml/2006/main" w="7144">
             <a:solidFill>
-              <a:srgbClr val="748092"/>
+              <a:srgbClr val="8D5560"/>
             </a:solidFill>
             <a:prstDash val="solid"/>
           </a:ln>
@@ -11976,7 +11787,7 @@
             </a:avLst>
           </a:prstGeom>
           <a:solidFill xmlns:a="http://schemas.openxmlformats.org/drawingml/2006/main">
-            <a:srgbClr val="EEF3FF"/>
+            <a:srgbClr val="F7EFF1"/>
           </a:solidFill>
           <a:ln xmlns:a="http://schemas.openxmlformats.org/drawingml/2006/main" w="9525">
             <a:solidFill>
@@ -12042,7 +11853,7 @@
             <a:r>
               <a:rPr sz="1275" b="1">
                 <a:solidFill>
-                  <a:srgbClr val="2F5EF5"/>
+                  <a:srgbClr val="7A2636"/>
                 </a:solidFill>
                 <a:latin typeface="Aptos"/>
                 <a:ea typeface="Aptos"/>
@@ -12700,7 +12511,7 @@
         </p:spPr>
         <p:txBody>
           <a:bodyPr xmlns:a="http://schemas.openxmlformats.org/drawingml/2006/main" wrap="square" lIns="0" tIns="0" rIns="0" bIns="0" anchor="t">
-            <a:normAutofit/>
+            <a:normAutofit fontScale="100000"/>
           </a:bodyPr>
           <a:lstStyle xmlns:a="http://schemas.openxmlformats.org/drawingml/2006/main"/>
           <a:p xmlns:a="http://schemas.openxmlformats.org/drawingml/2006/main">
@@ -12721,7 +12532,7 @@
             <a:r>
               <a:rPr sz="825" b="0">
                 <a:solidFill>
-                  <a:srgbClr val="657184"/>
+                  <a:srgbClr val="5E6B7D"/>
                 </a:solidFill>
                 <a:latin typeface="Aptos"/>
                 <a:ea typeface="Aptos"/>
@@ -12754,10 +12565,12 @@
           <a:prstGeom xmlns:a="http://schemas.openxmlformats.org/drawingml/2006/main" prst="line">
             <a:avLst/>
           </a:prstGeom>
-          <a:noFill xmlns:a="http://schemas.openxmlformats.org/drawingml/2006/main"/>
-          <a:ln xmlns:a="http://schemas.openxmlformats.org/drawingml/2006/main" w="9525">
+          <a:solidFill xmlns:a="http://schemas.openxmlformats.org/drawingml/2006/main">
+            <a:srgbClr val="8D5560"/>
+          </a:solidFill>
+          <a:ln xmlns:a="http://schemas.openxmlformats.org/drawingml/2006/main" w="7144">
             <a:solidFill>
-              <a:srgbClr val="748092"/>
+              <a:srgbClr val="8D5560"/>
             </a:solidFill>
             <a:prstDash val="solid"/>
           </a:ln>
@@ -12914,7 +12727,7 @@
         </p:spPr>
         <p:txBody>
           <a:bodyPr xmlns:a="http://schemas.openxmlformats.org/drawingml/2006/main" wrap="square" lIns="0" tIns="0" rIns="0" bIns="0" anchor="t">
-            <a:normAutofit/>
+            <a:normAutofit fontScale="100000"/>
           </a:bodyPr>
           <a:lstStyle xmlns:a="http://schemas.openxmlformats.org/drawingml/2006/main"/>
           <a:p xmlns:a="http://schemas.openxmlformats.org/drawingml/2006/main">
@@ -12941,7 +12754,7 @@
                 <a:ea typeface="Aptos"/>
                 <a:cs typeface="Aptos"/>
               </a:rPr>
-              <a:t>Усмени проверава да ли студент уме да повеже концепт са одлуком коју је тим применио на пројекту.</a:t>
+              <a:t>Студент повезује концепте предмета са безбедносним и архитектонским одлукама примењеним на пројекту.</a:t>
             </a:r>
           </a:p>
         </p:txBody>
@@ -13037,7 +12850,7 @@
             <a:r>
               <a:rPr sz="1238" b="1">
                 <a:solidFill>
-                  <a:srgbClr val="2F5EF5"/>
+                  <a:srgbClr val="7A2636"/>
                 </a:solidFill>
                 <a:latin typeface="Aptos"/>
                 <a:ea typeface="Aptos"/>
@@ -13419,7 +13232,7 @@
             </a:avLst>
           </a:prstGeom>
           <a:solidFill xmlns:a="http://schemas.openxmlformats.org/drawingml/2006/main">
-            <a:srgbClr val="EEF3FF"/>
+            <a:srgbClr val="F7EFF1"/>
           </a:solidFill>
           <a:ln xmlns:a="http://schemas.openxmlformats.org/drawingml/2006/main" w="9525">
             <a:solidFill>
@@ -13485,7 +13298,7 @@
             <a:r>
               <a:rPr sz="1238" b="1">
                 <a:solidFill>
-                  <a:srgbClr val="2F5EF5"/>
+                  <a:srgbClr val="7A2636"/>
                 </a:solidFill>
                 <a:latin typeface="Aptos"/>
                 <a:ea typeface="Aptos"/>
@@ -13643,7 +13456,7 @@
             </a:avLst>
           </a:prstGeom>
           <a:solidFill xmlns:a="http://schemas.openxmlformats.org/drawingml/2006/main">
-            <a:srgbClr val="F5F0FF"/>
+            <a:srgbClr val="F7F4F5"/>
           </a:solidFill>
           <a:ln xmlns:a="http://schemas.openxmlformats.org/drawingml/2006/main" w="9525">
             <a:solidFill>
@@ -13709,7 +13522,7 @@
             <a:r>
               <a:rPr sz="1238" b="1">
                 <a:solidFill>
-                  <a:srgbClr val="7651D4"/>
+                  <a:srgbClr val="7A2636"/>
                 </a:solidFill>
                 <a:latin typeface="Aptos"/>
                 <a:ea typeface="Aptos"/>
@@ -14068,7 +13881,7 @@
       </p:sp>
       <p:cxnSp>
         <p:nvCxnSpPr>
-          <p:cNvPr id="237" name="Straight Arrow Connector 115"/>
+          <p:cNvPr id="353" name="Straight Arrow Connector 115"/>
           <p:cNvCxnSpPr>
             <a:stCxn xmlns:a="http://schemas.openxmlformats.org/drawingml/2006/main" id="6" idx="3"/>
             <a:endCxn xmlns:a="http://schemas.openxmlformats.org/drawingml/2006/main" id="10" idx="1"/>
@@ -14094,7 +13907,7 @@
       </p:cxnSp>
       <p:cxnSp>
         <p:nvCxnSpPr>
-          <p:cNvPr id="238" name="Straight Arrow Connector 116"/>
+          <p:cNvPr id="354" name="Straight Arrow Connector 116"/>
           <p:cNvCxnSpPr>
             <a:stCxn xmlns:a="http://schemas.openxmlformats.org/drawingml/2006/main" id="10" idx="3"/>
             <a:endCxn xmlns:a="http://schemas.openxmlformats.org/drawingml/2006/main" id="14" idx="1"/>
@@ -14120,7 +13933,7 @@
       </p:cxnSp>
       <p:cxnSp>
         <p:nvCxnSpPr>
-          <p:cNvPr id="239" name="Straight Arrow Connector 117"/>
+          <p:cNvPr id="355" name="Straight Arrow Connector 117"/>
           <p:cNvCxnSpPr>
             <a:stCxn xmlns:a="http://schemas.openxmlformats.org/drawingml/2006/main" id="14" idx="3"/>
             <a:endCxn xmlns:a="http://schemas.openxmlformats.org/drawingml/2006/main" id="18" idx="1"/>
@@ -14146,7 +13959,7 @@
       </p:cxnSp>
       <p:cxnSp>
         <p:nvCxnSpPr>
-          <p:cNvPr id="240" name="Straight Arrow Connector 118"/>
+          <p:cNvPr id="356" name="Straight Arrow Connector 118"/>
           <p:cNvCxnSpPr>
             <a:stCxn xmlns:a="http://schemas.openxmlformats.org/drawingml/2006/main" id="18" idx="3"/>
             <a:endCxn xmlns:a="http://schemas.openxmlformats.org/drawingml/2006/main" id="22" idx="1"/>
@@ -14195,11 +14008,11 @@
             </a:avLst>
           </a:prstGeom>
           <a:solidFill xmlns:a="http://schemas.openxmlformats.org/drawingml/2006/main">
-            <a:srgbClr val="EEF3FF"/>
+            <a:srgbClr val="F7EFF1"/>
           </a:solidFill>
           <a:ln xmlns:a="http://schemas.openxmlformats.org/drawingml/2006/main" w="8573">
             <a:solidFill>
-              <a:srgbClr val="CAD7F2"/>
+              <a:srgbClr val="DBC7CC"/>
             </a:solidFill>
             <a:prstDash val="solid"/>
           </a:ln>
@@ -14230,7 +14043,7 @@
             </a:avLst>
           </a:prstGeom>
           <a:solidFill xmlns:a="http://schemas.openxmlformats.org/drawingml/2006/main">
-            <a:srgbClr val="2F5EF5"/>
+            <a:srgbClr val="7A2636"/>
           </a:solidFill>
           <a:ln xmlns:a="http://schemas.openxmlformats.org/drawingml/2006/main" w="0">
             <a:noFill/>
@@ -14271,6 +14084,7 @@
           <a:lstStyle xmlns:a="http://schemas.openxmlformats.org/drawingml/2006/main"/>
           <a:p xmlns:a="http://schemas.openxmlformats.org/drawingml/2006/main">
             <a:pPr>
+              <a:buNone/>
               <a:defRPr sz="1200" b="1">
                 <a:solidFill>
                   <a:srgbClr val="2F5EF5"/>
@@ -14283,7 +14097,7 @@
             <a:r>
               <a:rPr sz="1200" b="1">
                 <a:solidFill>
-                  <a:srgbClr val="2F5EF5"/>
+                  <a:srgbClr val="7A2636"/>
                 </a:solidFill>
                 <a:latin typeface="Aptos"/>
                 <a:ea typeface="Aptos"/>
@@ -14328,6 +14142,7 @@
           <a:lstStyle xmlns:a="http://schemas.openxmlformats.org/drawingml/2006/main"/>
           <a:p xmlns:a="http://schemas.openxmlformats.org/drawingml/2006/main">
             <a:pPr>
+              <a:buNone/>
               <a:defRPr sz="2025" b="1">
                 <a:solidFill>
                   <a:srgbClr val="1B2432"/>
@@ -14385,6 +14200,7 @@
           <a:lstStyle xmlns:a="http://schemas.openxmlformats.org/drawingml/2006/main"/>
           <a:p xmlns:a="http://schemas.openxmlformats.org/drawingml/2006/main">
             <a:pPr>
+              <a:buNone/>
               <a:defRPr sz="1275" b="0">
                 <a:solidFill>
                   <a:srgbClr val="52637B"/>
@@ -14466,7 +14282,7 @@
         </p:spPr>
         <p:txBody>
           <a:bodyPr xmlns:a="http://schemas.openxmlformats.org/drawingml/2006/main" wrap="square" lIns="0" tIns="0" rIns="0" bIns="0" anchor="t">
-            <a:normAutofit/>
+            <a:normAutofit fontScale="100000"/>
           </a:bodyPr>
           <a:lstStyle xmlns:a="http://schemas.openxmlformats.org/drawingml/2006/main"/>
           <a:p xmlns:a="http://schemas.openxmlformats.org/drawingml/2006/main">
@@ -14487,7 +14303,7 @@
             <a:r>
               <a:rPr sz="825" b="0">
                 <a:solidFill>
-                  <a:srgbClr val="657184"/>
+                  <a:srgbClr val="5E6B7D"/>
                 </a:solidFill>
                 <a:latin typeface="Aptos"/>
                 <a:ea typeface="Aptos"/>
@@ -14520,10 +14336,12 @@
           <a:prstGeom xmlns:a="http://schemas.openxmlformats.org/drawingml/2006/main" prst="line">
             <a:avLst/>
           </a:prstGeom>
-          <a:noFill xmlns:a="http://schemas.openxmlformats.org/drawingml/2006/main"/>
-          <a:ln xmlns:a="http://schemas.openxmlformats.org/drawingml/2006/main" w="9525">
+          <a:solidFill xmlns:a="http://schemas.openxmlformats.org/drawingml/2006/main">
+            <a:srgbClr val="8D5560"/>
+          </a:solidFill>
+          <a:ln xmlns:a="http://schemas.openxmlformats.org/drawingml/2006/main" w="7144">
             <a:solidFill>
-              <a:srgbClr val="748092"/>
+              <a:srgbClr val="8D5560"/>
             </a:solidFill>
             <a:prstDash val="solid"/>
           </a:ln>
@@ -14680,7 +14498,7 @@
         </p:spPr>
         <p:txBody>
           <a:bodyPr xmlns:a="http://schemas.openxmlformats.org/drawingml/2006/main" wrap="square" lIns="0" tIns="0" rIns="0" bIns="0" anchor="t">
-            <a:normAutofit/>
+            <a:normAutofit fontScale="100000"/>
           </a:bodyPr>
           <a:lstStyle xmlns:a="http://schemas.openxmlformats.org/drawingml/2006/main"/>
           <a:p xmlns:a="http://schemas.openxmlformats.org/drawingml/2006/main">
@@ -14707,7 +14525,7 @@
                 <a:ea typeface="Aptos"/>
                 <a:cs typeface="Aptos"/>
               </a:rPr>
-              <a:t>Термини, измене и организациона обавештења важе тек када се објаве путем званичних канала предмета.</a:t>
+              <a:t>Термини, измене и организациона обавештења важе након објављивања путем званичних канала предмета.</a:t>
             </a:r>
           </a:p>
         </p:txBody>
@@ -14737,7 +14555,7 @@
             </a:avLst>
           </a:prstGeom>
           <a:solidFill xmlns:a="http://schemas.openxmlformats.org/drawingml/2006/main">
-            <a:srgbClr val="EEF3FF"/>
+            <a:srgbClr val="F7EFF1"/>
           </a:solidFill>
           <a:ln xmlns:a="http://schemas.openxmlformats.org/drawingml/2006/main" w="9525">
             <a:solidFill>
@@ -14803,7 +14621,7 @@
             <a:r>
               <a:rPr sz="1275" b="1">
                 <a:solidFill>
-                  <a:srgbClr val="2F5EF5"/>
+                  <a:srgbClr val="7A2636"/>
                 </a:solidFill>
                 <a:latin typeface="Aptos"/>
                 <a:ea typeface="Aptos"/>
@@ -15218,7 +15036,7 @@
         </p:spPr>
         <p:txBody>
           <a:bodyPr xmlns:a="http://schemas.openxmlformats.org/drawingml/2006/main" wrap="square" lIns="0" tIns="0" rIns="0" bIns="0" anchor="t">
-            <a:normAutofit/>
+            <a:normAutofit fontScale="100000"/>
           </a:bodyPr>
           <a:lstStyle xmlns:a="http://schemas.openxmlformats.org/drawingml/2006/main"/>
           <a:p xmlns:a="http://schemas.openxmlformats.org/drawingml/2006/main">
@@ -15239,7 +15057,7 @@
             <a:r>
               <a:rPr sz="825" b="0">
                 <a:solidFill>
-                  <a:srgbClr val="657184"/>
+                  <a:srgbClr val="5E6B7D"/>
                 </a:solidFill>
                 <a:latin typeface="Aptos"/>
                 <a:ea typeface="Aptos"/>
@@ -15272,10 +15090,12 @@
           <a:prstGeom xmlns:a="http://schemas.openxmlformats.org/drawingml/2006/main" prst="line">
             <a:avLst/>
           </a:prstGeom>
-          <a:noFill xmlns:a="http://schemas.openxmlformats.org/drawingml/2006/main"/>
-          <a:ln xmlns:a="http://schemas.openxmlformats.org/drawingml/2006/main" w="9525">
+          <a:solidFill xmlns:a="http://schemas.openxmlformats.org/drawingml/2006/main">
+            <a:srgbClr val="8D5560"/>
+          </a:solidFill>
+          <a:ln xmlns:a="http://schemas.openxmlformats.org/drawingml/2006/main" w="7144">
             <a:solidFill>
-              <a:srgbClr val="748092"/>
+              <a:srgbClr val="8D5560"/>
             </a:solidFill>
             <a:prstDash val="solid"/>
           </a:ln>
@@ -15371,7 +15191,7 @@
         </p:spPr>
         <p:txBody>
           <a:bodyPr xmlns:a="http://schemas.openxmlformats.org/drawingml/2006/main" wrap="square" lIns="0" tIns="0" rIns="0" bIns="0" anchor="t">
-            <a:normAutofit/>
+            <a:normAutofit fontScale="100000"/>
           </a:bodyPr>
           <a:lstStyle xmlns:a="http://schemas.openxmlformats.org/drawingml/2006/main"/>
           <a:p xmlns:a="http://schemas.openxmlformats.org/drawingml/2006/main">
@@ -15398,7 +15218,7 @@
                 <a:ea typeface="Aptos Display"/>
                 <a:cs typeface="Aptos Display"/>
               </a:rPr>
-              <a:t>Безбедност се гради као доказив ланац</a:t>
+              <a:t>Безбедносни захтев, контрола и доказ</a:t>
             </a:r>
           </a:p>
         </p:txBody>
@@ -15432,7 +15252,7 @@
         </p:spPr>
         <p:txBody>
           <a:bodyPr xmlns:a="http://schemas.openxmlformats.org/drawingml/2006/main" wrap="square" lIns="0" tIns="0" rIns="0" bIns="0" anchor="t">
-            <a:normAutofit/>
+            <a:normAutofit fontScale="100000"/>
           </a:bodyPr>
           <a:lstStyle xmlns:a="http://schemas.openxmlformats.org/drawingml/2006/main"/>
           <a:p xmlns:a="http://schemas.openxmlformats.org/drawingml/2006/main">
@@ -15459,7 +15279,7 @@
                 <a:ea typeface="Aptos"/>
                 <a:cs typeface="Aptos"/>
               </a:rPr>
-              <a:t>Не полазимо од алата, већ од онога што штитимо и начина на који проверавамо одлуку.</a:t>
+              <a:t>Анализа полази од имовине и претње, а завршава се провером изабране контроле.</a:t>
             </a:r>
           </a:p>
         </p:txBody>
@@ -15555,7 +15375,7 @@
             <a:r>
               <a:rPr sz="1238" b="1">
                 <a:solidFill>
-                  <a:srgbClr val="2F5EF5"/>
+                  <a:srgbClr val="7A2636"/>
                 </a:solidFill>
                 <a:latin typeface="Aptos"/>
                 <a:ea typeface="Aptos"/>
@@ -15937,7 +15757,7 @@
             </a:avLst>
           </a:prstGeom>
           <a:solidFill xmlns:a="http://schemas.openxmlformats.org/drawingml/2006/main">
-            <a:srgbClr val="EEF3FF"/>
+            <a:srgbClr val="F7EFF1"/>
           </a:solidFill>
           <a:ln xmlns:a="http://schemas.openxmlformats.org/drawingml/2006/main" w="9525">
             <a:solidFill>
@@ -16003,7 +15823,7 @@
             <a:r>
               <a:rPr sz="1238" b="1">
                 <a:solidFill>
-                  <a:srgbClr val="2F5EF5"/>
+                  <a:srgbClr val="7A2636"/>
                 </a:solidFill>
                 <a:latin typeface="Aptos"/>
                 <a:ea typeface="Aptos"/>
@@ -16161,7 +15981,7 @@
             </a:avLst>
           </a:prstGeom>
           <a:solidFill xmlns:a="http://schemas.openxmlformats.org/drawingml/2006/main">
-            <a:srgbClr val="F5F0FF"/>
+            <a:srgbClr val="F7F4F5"/>
           </a:solidFill>
           <a:ln xmlns:a="http://schemas.openxmlformats.org/drawingml/2006/main" w="9525">
             <a:solidFill>
@@ -16227,7 +16047,7 @@
             <a:r>
               <a:rPr sz="1238" b="1">
                 <a:solidFill>
-                  <a:srgbClr val="7651D4"/>
+                  <a:srgbClr val="7A2636"/>
                 </a:solidFill>
                 <a:latin typeface="Aptos"/>
                 <a:ea typeface="Aptos"/>
@@ -16586,7 +16406,7 @@
       </p:sp>
       <p:cxnSp>
         <p:nvCxnSpPr>
-          <p:cNvPr id="235" name="Straight Arrow Connector 114"/>
+          <p:cNvPr id="351" name="Straight Arrow Connector 114"/>
           <p:cNvCxnSpPr>
             <a:stCxn xmlns:a="http://schemas.openxmlformats.org/drawingml/2006/main" id="6" idx="3"/>
             <a:endCxn xmlns:a="http://schemas.openxmlformats.org/drawingml/2006/main" id="10" idx="1"/>
@@ -16612,7 +16432,7 @@
       </p:cxnSp>
       <p:cxnSp>
         <p:nvCxnSpPr>
-          <p:cNvPr id="236" name="Straight Arrow Connector 115"/>
+          <p:cNvPr id="352" name="Straight Arrow Connector 115"/>
           <p:cNvCxnSpPr>
             <a:stCxn xmlns:a="http://schemas.openxmlformats.org/drawingml/2006/main" id="10" idx="3"/>
             <a:endCxn xmlns:a="http://schemas.openxmlformats.org/drawingml/2006/main" id="14" idx="1"/>
@@ -16638,7 +16458,7 @@
       </p:cxnSp>
       <p:cxnSp>
         <p:nvCxnSpPr>
-          <p:cNvPr id="237" name="Straight Arrow Connector 116"/>
+          <p:cNvPr id="353" name="Straight Arrow Connector 116"/>
           <p:cNvCxnSpPr>
             <a:stCxn xmlns:a="http://schemas.openxmlformats.org/drawingml/2006/main" id="14" idx="3"/>
             <a:endCxn xmlns:a="http://schemas.openxmlformats.org/drawingml/2006/main" id="18" idx="1"/>
@@ -16664,7 +16484,7 @@
       </p:cxnSp>
       <p:cxnSp>
         <p:nvCxnSpPr>
-          <p:cNvPr id="238" name="Straight Arrow Connector 117"/>
+          <p:cNvPr id="354" name="Straight Arrow Connector 117"/>
           <p:cNvCxnSpPr>
             <a:stCxn xmlns:a="http://schemas.openxmlformats.org/drawingml/2006/main" id="18" idx="3"/>
             <a:endCxn xmlns:a="http://schemas.openxmlformats.org/drawingml/2006/main" id="22" idx="1"/>
@@ -16713,11 +16533,11 @@
             </a:avLst>
           </a:prstGeom>
           <a:solidFill xmlns:a="http://schemas.openxmlformats.org/drawingml/2006/main">
-            <a:srgbClr val="EEF3FF"/>
+            <a:srgbClr val="F7EFF1"/>
           </a:solidFill>
           <a:ln xmlns:a="http://schemas.openxmlformats.org/drawingml/2006/main" w="8573">
             <a:solidFill>
-              <a:srgbClr val="CAD7F2"/>
+              <a:srgbClr val="DBC7CC"/>
             </a:solidFill>
             <a:prstDash val="solid"/>
           </a:ln>
@@ -16748,7 +16568,7 @@
             </a:avLst>
           </a:prstGeom>
           <a:solidFill xmlns:a="http://schemas.openxmlformats.org/drawingml/2006/main">
-            <a:srgbClr val="2F5EF5"/>
+            <a:srgbClr val="7A2636"/>
           </a:solidFill>
           <a:ln xmlns:a="http://schemas.openxmlformats.org/drawingml/2006/main" w="0">
             <a:noFill/>
@@ -16789,6 +16609,7 @@
           <a:lstStyle xmlns:a="http://schemas.openxmlformats.org/drawingml/2006/main"/>
           <a:p xmlns:a="http://schemas.openxmlformats.org/drawingml/2006/main">
             <a:pPr>
+              <a:buNone/>
               <a:defRPr sz="1200" b="1">
                 <a:solidFill>
                   <a:srgbClr val="2F5EF5"/>
@@ -16801,7 +16622,7 @@
             <a:r>
               <a:rPr sz="1200" b="1">
                 <a:solidFill>
-                  <a:srgbClr val="2F5EF5"/>
+                  <a:srgbClr val="7A2636"/>
                 </a:solidFill>
                 <a:latin typeface="Aptos"/>
                 <a:ea typeface="Aptos"/>
@@ -16846,6 +16667,7 @@
           <a:lstStyle xmlns:a="http://schemas.openxmlformats.org/drawingml/2006/main"/>
           <a:p xmlns:a="http://schemas.openxmlformats.org/drawingml/2006/main">
             <a:pPr>
+              <a:buNone/>
               <a:defRPr sz="1425" b="1">
                 <a:solidFill>
                   <a:srgbClr val="1B2432"/>
@@ -16927,7 +16749,7 @@
         </p:spPr>
         <p:txBody>
           <a:bodyPr xmlns:a="http://schemas.openxmlformats.org/drawingml/2006/main" wrap="square" lIns="0" tIns="0" rIns="0" bIns="0" anchor="t">
-            <a:normAutofit/>
+            <a:normAutofit fontScale="100000"/>
           </a:bodyPr>
           <a:lstStyle xmlns:a="http://schemas.openxmlformats.org/drawingml/2006/main"/>
           <a:p xmlns:a="http://schemas.openxmlformats.org/drawingml/2006/main">
@@ -16948,7 +16770,7 @@
             <a:r>
               <a:rPr sz="825" b="0">
                 <a:solidFill>
-                  <a:srgbClr val="657184"/>
+                  <a:srgbClr val="5E6B7D"/>
                 </a:solidFill>
                 <a:latin typeface="Aptos"/>
                 <a:ea typeface="Aptos"/>
@@ -16981,10 +16803,12 @@
           <a:prstGeom xmlns:a="http://schemas.openxmlformats.org/drawingml/2006/main" prst="line">
             <a:avLst/>
           </a:prstGeom>
-          <a:noFill xmlns:a="http://schemas.openxmlformats.org/drawingml/2006/main"/>
-          <a:ln xmlns:a="http://schemas.openxmlformats.org/drawingml/2006/main" w="9525">
+          <a:solidFill xmlns:a="http://schemas.openxmlformats.org/drawingml/2006/main">
+            <a:srgbClr val="8D5560"/>
+          </a:solidFill>
+          <a:ln xmlns:a="http://schemas.openxmlformats.org/drawingml/2006/main" w="7144">
             <a:solidFill>
-              <a:srgbClr val="748092"/>
+              <a:srgbClr val="8D5560"/>
             </a:solidFill>
             <a:prstDash val="solid"/>
           </a:ln>
@@ -17080,7 +16904,7 @@
         </p:spPr>
         <p:txBody>
           <a:bodyPr xmlns:a="http://schemas.openxmlformats.org/drawingml/2006/main" wrap="square" lIns="0" tIns="0" rIns="0" bIns="0" anchor="t">
-            <a:normAutofit/>
+            <a:normAutofit fontScale="100000"/>
           </a:bodyPr>
           <a:lstStyle xmlns:a="http://schemas.openxmlformats.org/drawingml/2006/main"/>
           <a:p xmlns:a="http://schemas.openxmlformats.org/drawingml/2006/main">
@@ -17107,7 +16931,7 @@
                 <a:ea typeface="Aptos Display"/>
                 <a:cs typeface="Aptos Display"/>
               </a:rPr>
-              <a:t>Први кораци</a:t>
+              <a:t>Организација рада на почетку семестра</a:t>
             </a:r>
           </a:p>
         </p:txBody>
@@ -17141,7 +16965,7 @@
         </p:spPr>
         <p:txBody>
           <a:bodyPr xmlns:a="http://schemas.openxmlformats.org/drawingml/2006/main" wrap="square" lIns="0" tIns="0" rIns="0" bIns="0" anchor="t">
-            <a:normAutofit/>
+            <a:normAutofit fontScale="100000"/>
           </a:bodyPr>
           <a:lstStyle xmlns:a="http://schemas.openxmlformats.org/drawingml/2006/main"/>
           <a:p xmlns:a="http://schemas.openxmlformats.org/drawingml/2006/main">
@@ -17168,7 +16992,7 @@
                 <a:ea typeface="Aptos"/>
                 <a:cs typeface="Aptos"/>
               </a:rPr>
-              <a:t>Почетак семестра служи да тим постави основу за проверљив и континуиран рад.</a:t>
+              <a:t>Тим на почетку семестра дефинише одговорности, репозиторијум, границу пројектне целине и почетни backlog.</a:t>
             </a:r>
           </a:p>
         </p:txBody>
@@ -17264,7 +17088,7 @@
             <a:r>
               <a:rPr sz="1238" b="1">
                 <a:solidFill>
-                  <a:srgbClr val="2F5EF5"/>
+                  <a:srgbClr val="7A2636"/>
                 </a:solidFill>
                 <a:latin typeface="Aptos"/>
                 <a:ea typeface="Aptos"/>
@@ -17422,7 +17246,7 @@
             </a:avLst>
           </a:prstGeom>
           <a:solidFill xmlns:a="http://schemas.openxmlformats.org/drawingml/2006/main">
-            <a:srgbClr val="EEF3FF"/>
+            <a:srgbClr val="F7EFF1"/>
           </a:solidFill>
           <a:ln xmlns:a="http://schemas.openxmlformats.org/drawingml/2006/main" w="9525">
             <a:solidFill>
@@ -17488,7 +17312,7 @@
             <a:r>
               <a:rPr sz="1238" b="1">
                 <a:solidFill>
-                  <a:srgbClr val="2F5EF5"/>
+                  <a:srgbClr val="7A2636"/>
                 </a:solidFill>
                 <a:latin typeface="Aptos"/>
                 <a:ea typeface="Aptos"/>
@@ -17646,7 +17470,7 @@
             </a:avLst>
           </a:prstGeom>
           <a:solidFill xmlns:a="http://schemas.openxmlformats.org/drawingml/2006/main">
-            <a:srgbClr val="F5F0FF"/>
+            <a:srgbClr val="F7F4F5"/>
           </a:solidFill>
           <a:ln xmlns:a="http://schemas.openxmlformats.org/drawingml/2006/main" w="9525">
             <a:solidFill>
@@ -17712,7 +17536,7 @@
             <a:r>
               <a:rPr sz="1238" b="1">
                 <a:solidFill>
-                  <a:srgbClr val="7651D4"/>
+                  <a:srgbClr val="7A2636"/>
                 </a:solidFill>
                 <a:latin typeface="Aptos"/>
                 <a:ea typeface="Aptos"/>
@@ -18071,7 +17895,7 @@
       </p:sp>
       <p:cxnSp>
         <p:nvCxnSpPr>
-          <p:cNvPr id="193" name="Straight Arrow Connector 96"/>
+          <p:cNvPr id="289" name="Straight Arrow Connector 96"/>
           <p:cNvCxnSpPr>
             <a:stCxn xmlns:a="http://schemas.openxmlformats.org/drawingml/2006/main" id="6" idx="3"/>
             <a:endCxn xmlns:a="http://schemas.openxmlformats.org/drawingml/2006/main" id="10" idx="1"/>
@@ -18097,7 +17921,7 @@
       </p:cxnSp>
       <p:cxnSp>
         <p:nvCxnSpPr>
-          <p:cNvPr id="194" name="Straight Arrow Connector 97"/>
+          <p:cNvPr id="290" name="Straight Arrow Connector 97"/>
           <p:cNvCxnSpPr>
             <a:stCxn xmlns:a="http://schemas.openxmlformats.org/drawingml/2006/main" id="10" idx="3"/>
             <a:endCxn xmlns:a="http://schemas.openxmlformats.org/drawingml/2006/main" id="14" idx="1"/>
@@ -18123,7 +17947,7 @@
       </p:cxnSp>
       <p:cxnSp>
         <p:nvCxnSpPr>
-          <p:cNvPr id="195" name="Straight Arrow Connector 98"/>
+          <p:cNvPr id="291" name="Straight Arrow Connector 98"/>
           <p:cNvCxnSpPr>
             <a:stCxn xmlns:a="http://schemas.openxmlformats.org/drawingml/2006/main" id="14" idx="3"/>
             <a:endCxn xmlns:a="http://schemas.openxmlformats.org/drawingml/2006/main" id="18" idx="1"/>
@@ -18362,7 +18186,7 @@
         </p:spPr>
         <p:txBody>
           <a:bodyPr xmlns:a="http://schemas.openxmlformats.org/drawingml/2006/main" wrap="square" lIns="0" tIns="0" rIns="0" bIns="0" anchor="t">
-            <a:normAutofit/>
+            <a:normAutofit fontScale="100000"/>
           </a:bodyPr>
           <a:lstStyle xmlns:a="http://schemas.openxmlformats.org/drawingml/2006/main"/>
           <a:p xmlns:a="http://schemas.openxmlformats.org/drawingml/2006/main">
@@ -18383,7 +18207,7 @@
             <a:r>
               <a:rPr sz="825" b="0">
                 <a:solidFill>
-                  <a:srgbClr val="657184"/>
+                  <a:srgbClr val="5E6B7D"/>
                 </a:solidFill>
                 <a:latin typeface="Aptos"/>
                 <a:ea typeface="Aptos"/>
@@ -18416,10 +18240,12 @@
           <a:prstGeom xmlns:a="http://schemas.openxmlformats.org/drawingml/2006/main" prst="line">
             <a:avLst/>
           </a:prstGeom>
-          <a:noFill xmlns:a="http://schemas.openxmlformats.org/drawingml/2006/main"/>
-          <a:ln xmlns:a="http://schemas.openxmlformats.org/drawingml/2006/main" w="9525">
+          <a:solidFill xmlns:a="http://schemas.openxmlformats.org/drawingml/2006/main">
+            <a:srgbClr val="8D5560"/>
+          </a:solidFill>
+          <a:ln xmlns:a="http://schemas.openxmlformats.org/drawingml/2006/main" w="7144">
             <a:solidFill>
-              <a:srgbClr val="748092"/>
+              <a:srgbClr val="8D5560"/>
             </a:solidFill>
             <a:prstDash val="solid"/>
           </a:ln>
@@ -18515,7 +18341,7 @@
         </p:spPr>
         <p:txBody>
           <a:bodyPr xmlns:a="http://schemas.openxmlformats.org/drawingml/2006/main" wrap="square" lIns="0" tIns="0" rIns="0" bIns="0" anchor="t">
-            <a:normAutofit/>
+            <a:normAutofit fontScale="100000"/>
           </a:bodyPr>
           <a:lstStyle xmlns:a="http://schemas.openxmlformats.org/drawingml/2006/main"/>
           <a:p xmlns:a="http://schemas.openxmlformats.org/drawingml/2006/main">
@@ -18542,7 +18368,7 @@
                 <a:ea typeface="Aptos Display"/>
                 <a:cs typeface="Aptos Display"/>
               </a:rPr>
-              <a:t>Два начина полагања</a:t>
+              <a:t>Начини полагања</a:t>
             </a:r>
           </a:p>
         </p:txBody>
@@ -18576,7 +18402,7 @@
         </p:spPr>
         <p:txBody>
           <a:bodyPr xmlns:a="http://schemas.openxmlformats.org/drawingml/2006/main" wrap="square" lIns="0" tIns="0" rIns="0" bIns="0" anchor="t">
-            <a:normAutofit/>
+            <a:normAutofit fontScale="95307"/>
           </a:bodyPr>
           <a:lstStyle xmlns:a="http://schemas.openxmlformats.org/drawingml/2006/main"/>
           <a:p xmlns:a="http://schemas.openxmlformats.org/drawingml/2006/main">
@@ -18603,7 +18429,7 @@
                 <a:ea typeface="Aptos"/>
                 <a:cs typeface="Aptos"/>
               </a:rPr>
-              <a:t>Оба пута завршавају се усменим испитом; разлика је у обиму пројекта и елиминационом тесту.</a:t>
+              <a:t>Оба начина завршавају се усменим испитом. Разликују се по обиму пројекта и обавези полагања елиминационог теста.</a:t>
             </a:r>
           </a:p>
         </p:txBody>
@@ -18633,7 +18459,7 @@
             </a:avLst>
           </a:prstGeom>
           <a:solidFill xmlns:a="http://schemas.openxmlformats.org/drawingml/2006/main">
-            <a:srgbClr val="EEF3FF"/>
+            <a:srgbClr val="F7EFF1"/>
           </a:solidFill>
           <a:ln xmlns:a="http://schemas.openxmlformats.org/drawingml/2006/main" w="9525">
             <a:solidFill>
@@ -18699,7 +18525,7 @@
             <a:r>
               <a:rPr sz="1275" b="1">
                 <a:solidFill>
-                  <a:srgbClr val="2F5EF5"/>
+                  <a:srgbClr val="7A2636"/>
                 </a:solidFill>
                 <a:latin typeface="Aptos"/>
                 <a:ea typeface="Aptos"/>
@@ -19304,7 +19130,7 @@
             </a:avLst>
           </a:prstGeom>
           <a:solidFill xmlns:a="http://schemas.openxmlformats.org/drawingml/2006/main">
-            <a:srgbClr val="EEF3FF"/>
+            <a:srgbClr val="F7EFF1"/>
           </a:solidFill>
           <a:ln xmlns:a="http://schemas.openxmlformats.org/drawingml/2006/main" w="9525">
             <a:solidFill>
@@ -19370,7 +19196,7 @@
             <a:r>
               <a:rPr sz="2250" b="1">
                 <a:solidFill>
-                  <a:srgbClr val="2F5EF5"/>
+                  <a:srgbClr val="7A2636"/>
                 </a:solidFill>
                 <a:latin typeface="Aptos Display"/>
                 <a:ea typeface="Aptos Display"/>
@@ -19431,7 +19257,7 @@
             <a:r>
               <a:rPr sz="1238" b="1">
                 <a:solidFill>
-                  <a:srgbClr val="2F5EF5"/>
+                  <a:srgbClr val="7A2636"/>
                 </a:solidFill>
                 <a:latin typeface="Aptos"/>
                 <a:ea typeface="Aptos"/>
@@ -19826,7 +19652,7 @@
         </p:spPr>
         <p:txBody>
           <a:bodyPr xmlns:a="http://schemas.openxmlformats.org/drawingml/2006/main" wrap="square" lIns="0" tIns="0" rIns="0" bIns="0" anchor="t">
-            <a:normAutofit/>
+            <a:normAutofit fontScale="100000"/>
           </a:bodyPr>
           <a:lstStyle xmlns:a="http://schemas.openxmlformats.org/drawingml/2006/main"/>
           <a:p xmlns:a="http://schemas.openxmlformats.org/drawingml/2006/main">
@@ -19847,7 +19673,7 @@
             <a:r>
               <a:rPr sz="825" b="0">
                 <a:solidFill>
-                  <a:srgbClr val="657184"/>
+                  <a:srgbClr val="5E6B7D"/>
                 </a:solidFill>
                 <a:latin typeface="Aptos"/>
                 <a:ea typeface="Aptos"/>
@@ -19880,10 +19706,12 @@
           <a:prstGeom xmlns:a="http://schemas.openxmlformats.org/drawingml/2006/main" prst="line">
             <a:avLst/>
           </a:prstGeom>
-          <a:noFill xmlns:a="http://schemas.openxmlformats.org/drawingml/2006/main"/>
-          <a:ln xmlns:a="http://schemas.openxmlformats.org/drawingml/2006/main" w="9525">
+          <a:solidFill xmlns:a="http://schemas.openxmlformats.org/drawingml/2006/main">
+            <a:srgbClr val="8D5560"/>
+          </a:solidFill>
+          <a:ln xmlns:a="http://schemas.openxmlformats.org/drawingml/2006/main" w="7144">
             <a:solidFill>
-              <a:srgbClr val="748092"/>
+              <a:srgbClr val="8D5560"/>
             </a:solidFill>
             <a:prstDash val="solid"/>
           </a:ln>
@@ -20040,7 +19868,7 @@
         </p:spPr>
         <p:txBody>
           <a:bodyPr xmlns:a="http://schemas.openxmlformats.org/drawingml/2006/main" wrap="square" lIns="0" tIns="0" rIns="0" bIns="0" anchor="t">
-            <a:normAutofit/>
+            <a:normAutofit fontScale="100000"/>
           </a:bodyPr>
           <a:lstStyle xmlns:a="http://schemas.openxmlformats.org/drawingml/2006/main"/>
           <a:p xmlns:a="http://schemas.openxmlformats.org/drawingml/2006/main">
@@ -20067,7 +19895,7 @@
                 <a:ea typeface="Aptos"/>
                 <a:cs typeface="Aptos"/>
               </a:rPr>
-              <a:t>Бодови се сабирају до максимума 100; додатни бодови не замењују обавезне компоненте.</a:t>
+              <a:t>Бодови се сабирају до максимума од 100. Додатни бодови не замењују обавезне компоненте.</a:t>
             </a:r>
           </a:p>
         </p:txBody>
@@ -20463,7 +20291,7 @@
             </a:avLst>
           </a:prstGeom>
           <a:solidFill xmlns:a="http://schemas.openxmlformats.org/drawingml/2006/main">
-            <a:srgbClr val="EEF3FF"/>
+            <a:srgbClr val="F7EFF1"/>
           </a:solidFill>
           <a:ln xmlns:a="http://schemas.openxmlformats.org/drawingml/2006/main" w="9525">
             <a:solidFill>
@@ -20813,7 +20641,7 @@
         </p:spPr>
         <p:txBody>
           <a:bodyPr xmlns:a="http://schemas.openxmlformats.org/drawingml/2006/main" wrap="square" lIns="0" tIns="0" rIns="0" bIns="0" anchor="ctr">
-            <a:normAutofit/>
+            <a:normAutofit fontScale="100000"/>
           </a:bodyPr>
           <a:lstStyle xmlns:a="http://schemas.openxmlformats.org/drawingml/2006/main"/>
           <a:p xmlns:a="http://schemas.openxmlformats.org/drawingml/2006/main">
@@ -20834,7 +20662,7 @@
             <a:r>
               <a:rPr sz="1425" b="1">
                 <a:solidFill>
-                  <a:srgbClr val="2F5EF5"/>
+                  <a:srgbClr val="7A2636"/>
                 </a:solidFill>
                 <a:latin typeface="Aptos"/>
                 <a:ea typeface="Aptos"/>
@@ -21316,7 +21144,7 @@
         </p:spPr>
         <p:txBody>
           <a:bodyPr xmlns:a="http://schemas.openxmlformats.org/drawingml/2006/main" wrap="square" lIns="0" tIns="0" rIns="0" bIns="0" anchor="ctr">
-            <a:normAutofit/>
+            <a:normAutofit fontScale="100000"/>
           </a:bodyPr>
           <a:lstStyle xmlns:a="http://schemas.openxmlformats.org/drawingml/2006/main"/>
           <a:p xmlns:a="http://schemas.openxmlformats.org/drawingml/2006/main">
@@ -21343,7 +21171,7 @@
                 <a:ea typeface="Aptos"/>
                 <a:cs typeface="Aptos"/>
               </a:rPr>
-              <a:t>Кључно правило</a:t>
+              <a:t>УСЛОВ БОДОВАЊА</a:t>
             </a:r>
           </a:p>
         </p:txBody>
@@ -21467,7 +21295,7 @@
         </p:spPr>
         <p:txBody>
           <a:bodyPr xmlns:a="http://schemas.openxmlformats.org/drawingml/2006/main" wrap="square" lIns="0" tIns="0" rIns="0" bIns="0" anchor="t">
-            <a:normAutofit/>
+            <a:normAutofit fontScale="100000"/>
           </a:bodyPr>
           <a:lstStyle xmlns:a="http://schemas.openxmlformats.org/drawingml/2006/main"/>
           <a:p xmlns:a="http://schemas.openxmlformats.org/drawingml/2006/main">
@@ -21488,7 +21316,7 @@
             <a:r>
               <a:rPr sz="825" b="0">
                 <a:solidFill>
-                  <a:srgbClr val="657184"/>
+                  <a:srgbClr val="5E6B7D"/>
                 </a:solidFill>
                 <a:latin typeface="Aptos"/>
                 <a:ea typeface="Aptos"/>
@@ -21521,10 +21349,12 @@
           <a:prstGeom xmlns:a="http://schemas.openxmlformats.org/drawingml/2006/main" prst="line">
             <a:avLst/>
           </a:prstGeom>
-          <a:noFill xmlns:a="http://schemas.openxmlformats.org/drawingml/2006/main"/>
-          <a:ln xmlns:a="http://schemas.openxmlformats.org/drawingml/2006/main" w="9525">
+          <a:solidFill xmlns:a="http://schemas.openxmlformats.org/drawingml/2006/main">
+            <a:srgbClr val="8D5560"/>
+          </a:solidFill>
+          <a:ln xmlns:a="http://schemas.openxmlformats.org/drawingml/2006/main" w="7144">
             <a:solidFill>
-              <a:srgbClr val="748092"/>
+              <a:srgbClr val="8D5560"/>
             </a:solidFill>
             <a:prstDash val="solid"/>
           </a:ln>
@@ -21620,7 +21450,7 @@
         </p:spPr>
         <p:txBody>
           <a:bodyPr xmlns:a="http://schemas.openxmlformats.org/drawingml/2006/main" wrap="square" lIns="0" tIns="0" rIns="0" bIns="0" anchor="t">
-            <a:normAutofit/>
+            <a:normAutofit fontScale="100000"/>
           </a:bodyPr>
           <a:lstStyle xmlns:a="http://schemas.openxmlformats.org/drawingml/2006/main"/>
           <a:p xmlns:a="http://schemas.openxmlformats.org/drawingml/2006/main">
@@ -21647,7 +21477,7 @@
                 <a:ea typeface="Aptos Display"/>
                 <a:cs typeface="Aptos Display"/>
               </a:rPr>
-              <a:t>Коначна оцена зависи од укупног збира</a:t>
+              <a:t>Формирање коначне оцене</a:t>
             </a:r>
           </a:p>
         </p:txBody>
@@ -21681,7 +21511,7 @@
         </p:spPr>
         <p:txBody>
           <a:bodyPr xmlns:a="http://schemas.openxmlformats.org/drawingml/2006/main" wrap="square" lIns="0" tIns="0" rIns="0" bIns="0" anchor="t">
-            <a:normAutofit/>
+            <a:normAutofit fontScale="100000"/>
           </a:bodyPr>
           <a:lstStyle xmlns:a="http://schemas.openxmlformats.org/drawingml/2006/main"/>
           <a:p xmlns:a="http://schemas.openxmlformats.org/drawingml/2006/main">
@@ -21708,7 +21538,7 @@
                 <a:ea typeface="Aptos"/>
                 <a:cs typeface="Aptos"/>
               </a:rPr>
-              <a:t>Распон је једноставан: сваких десет бодова подиже оцену за један ниво.</a:t>
+              <a:t>Оцена се утврђује на основу укупног броја бодова након испуњења свих обавезних компоненти.</a:t>
             </a:r>
           </a:p>
         </p:txBody>
@@ -21738,7 +21568,7 @@
             </a:avLst>
           </a:prstGeom>
           <a:solidFill xmlns:a="http://schemas.openxmlformats.org/drawingml/2006/main">
-            <a:srgbClr val="EEF3FF"/>
+            <a:srgbClr val="F7EFF1"/>
           </a:solidFill>
           <a:ln xmlns:a="http://schemas.openxmlformats.org/drawingml/2006/main" w="9525">
             <a:solidFill>
@@ -21783,7 +21613,7 @@
         </p:spPr>
         <p:txBody>
           <a:bodyPr xmlns:a="http://schemas.openxmlformats.org/drawingml/2006/main" wrap="square" lIns="0" tIns="0" rIns="0" bIns="0" anchor="ctr">
-            <a:normAutofit/>
+            <a:normAutofit fontScale="100000"/>
           </a:bodyPr>
           <a:lstStyle xmlns:a="http://schemas.openxmlformats.org/drawingml/2006/main"/>
           <a:p xmlns:a="http://schemas.openxmlformats.org/drawingml/2006/main">
@@ -21804,7 +21634,7 @@
             <a:r>
               <a:rPr sz="1650" b="1">
                 <a:solidFill>
-                  <a:srgbClr val="2F5EF5"/>
+                  <a:srgbClr val="7A2636"/>
                 </a:solidFill>
                 <a:latin typeface="Aptos"/>
                 <a:ea typeface="Aptos"/>
@@ -22410,7 +22240,7 @@
             </a:avLst>
           </a:prstGeom>
           <a:solidFill xmlns:a="http://schemas.openxmlformats.org/drawingml/2006/main">
-            <a:srgbClr val="F5F0FF"/>
+            <a:srgbClr val="F7F4F5"/>
           </a:solidFill>
           <a:ln xmlns:a="http://schemas.openxmlformats.org/drawingml/2006/main" w="9525">
             <a:solidFill>
@@ -22455,7 +22285,7 @@
         </p:spPr>
         <p:txBody>
           <a:bodyPr xmlns:a="http://schemas.openxmlformats.org/drawingml/2006/main" wrap="square" lIns="0" tIns="0" rIns="0" bIns="0" anchor="ctr">
-            <a:normAutofit/>
+            <a:normAutofit fontScale="100000"/>
           </a:bodyPr>
           <a:lstStyle xmlns:a="http://schemas.openxmlformats.org/drawingml/2006/main"/>
           <a:p xmlns:a="http://schemas.openxmlformats.org/drawingml/2006/main">
@@ -22476,7 +22306,7 @@
             <a:r>
               <a:rPr sz="1650" b="1">
                 <a:solidFill>
-                  <a:srgbClr val="7651D4"/>
+                  <a:srgbClr val="7A2636"/>
                 </a:solidFill>
                 <a:latin typeface="Aptos"/>
                 <a:ea typeface="Aptos"/>
@@ -22858,11 +22688,11 @@
             </a:avLst>
           </a:prstGeom>
           <a:solidFill xmlns:a="http://schemas.openxmlformats.org/drawingml/2006/main">
-            <a:srgbClr val="EEF3FF"/>
+            <a:srgbClr val="F7EFF1"/>
           </a:solidFill>
           <a:ln xmlns:a="http://schemas.openxmlformats.org/drawingml/2006/main" w="8573">
             <a:solidFill>
-              <a:srgbClr val="CAD7F2"/>
+              <a:srgbClr val="DBC7CC"/>
             </a:solidFill>
             <a:prstDash val="solid"/>
           </a:ln>
@@ -22893,7 +22723,7 @@
             </a:avLst>
           </a:prstGeom>
           <a:solidFill xmlns:a="http://schemas.openxmlformats.org/drawingml/2006/main">
-            <a:srgbClr val="2F5EF5"/>
+            <a:srgbClr val="7A2636"/>
           </a:solidFill>
           <a:ln xmlns:a="http://schemas.openxmlformats.org/drawingml/2006/main" w="0">
             <a:noFill/>
@@ -22934,6 +22764,7 @@
           <a:lstStyle xmlns:a="http://schemas.openxmlformats.org/drawingml/2006/main"/>
           <a:p xmlns:a="http://schemas.openxmlformats.org/drawingml/2006/main">
             <a:pPr>
+              <a:buNone/>
               <a:defRPr sz="1200" b="1">
                 <a:solidFill>
                   <a:srgbClr val="2F5EF5"/>
@@ -22946,7 +22777,7 @@
             <a:r>
               <a:rPr sz="1200" b="1">
                 <a:solidFill>
-                  <a:srgbClr val="2F5EF5"/>
+                  <a:srgbClr val="7A2636"/>
                 </a:solidFill>
                 <a:latin typeface="Aptos"/>
                 <a:ea typeface="Aptos"/>
@@ -22991,6 +22822,7 @@
           <a:lstStyle xmlns:a="http://schemas.openxmlformats.org/drawingml/2006/main"/>
           <a:p xmlns:a="http://schemas.openxmlformats.org/drawingml/2006/main">
             <a:pPr>
+              <a:buNone/>
               <a:defRPr sz="1388" b="1">
                 <a:solidFill>
                   <a:srgbClr val="1B2432"/>
@@ -23009,7 +22841,7 @@
                 <a:ea typeface="Aptos"/>
                 <a:cs typeface="Aptos"/>
               </a:rPr>
-              <a:t>Прво се испуњавају обавезе изабраног начина полагања; тек затим укупан број бодова одређује оцену.</a:t>
+              <a:t>Прво се испуњавају обавезе изабраног начина полагања. тек затим укупан број бодова одређује оцену.</a:t>
             </a:r>
           </a:p>
         </p:txBody>
@@ -23072,7 +22904,7 @@
         </p:spPr>
         <p:txBody>
           <a:bodyPr xmlns:a="http://schemas.openxmlformats.org/drawingml/2006/main" wrap="square" lIns="0" tIns="0" rIns="0" bIns="0" anchor="t">
-            <a:normAutofit/>
+            <a:normAutofit fontScale="100000"/>
           </a:bodyPr>
           <a:lstStyle xmlns:a="http://schemas.openxmlformats.org/drawingml/2006/main"/>
           <a:p xmlns:a="http://schemas.openxmlformats.org/drawingml/2006/main">
@@ -23093,7 +22925,7 @@
             <a:r>
               <a:rPr sz="825" b="0">
                 <a:solidFill>
-                  <a:srgbClr val="657184"/>
+                  <a:srgbClr val="5E6B7D"/>
                 </a:solidFill>
                 <a:latin typeface="Aptos"/>
                 <a:ea typeface="Aptos"/>
@@ -23126,10 +22958,12 @@
           <a:prstGeom xmlns:a="http://schemas.openxmlformats.org/drawingml/2006/main" prst="line">
             <a:avLst/>
           </a:prstGeom>
-          <a:noFill xmlns:a="http://schemas.openxmlformats.org/drawingml/2006/main"/>
-          <a:ln xmlns:a="http://schemas.openxmlformats.org/drawingml/2006/main" w="9525">
+          <a:solidFill xmlns:a="http://schemas.openxmlformats.org/drawingml/2006/main">
+            <a:srgbClr val="8D5560"/>
+          </a:solidFill>
+          <a:ln xmlns:a="http://schemas.openxmlformats.org/drawingml/2006/main" w="7144">
             <a:solidFill>
-              <a:srgbClr val="748092"/>
+              <a:srgbClr val="8D5560"/>
             </a:solidFill>
             <a:prstDash val="solid"/>
           </a:ln>
@@ -23225,7 +23059,7 @@
         </p:spPr>
         <p:txBody>
           <a:bodyPr xmlns:a="http://schemas.openxmlformats.org/drawingml/2006/main" wrap="square" lIns="0" tIns="0" rIns="0" bIns="0" anchor="t">
-            <a:normAutofit/>
+            <a:normAutofit fontScale="100000"/>
           </a:bodyPr>
           <a:lstStyle xmlns:a="http://schemas.openxmlformats.org/drawingml/2006/main"/>
           <a:p xmlns:a="http://schemas.openxmlformats.org/drawingml/2006/main">
@@ -23252,7 +23086,7 @@
                 <a:ea typeface="Aptos Display"/>
                 <a:cs typeface="Aptos Display"/>
               </a:rPr>
-              <a:t>Пројекат је континуиран рад, не изолована апликација</a:t>
+              <a:t>Организација пројектног рада</a:t>
             </a:r>
           </a:p>
         </p:txBody>
@@ -23286,7 +23120,7 @@
         </p:spPr>
         <p:txBody>
           <a:bodyPr xmlns:a="http://schemas.openxmlformats.org/drawingml/2006/main" wrap="square" lIns="0" tIns="0" rIns="0" bIns="0" anchor="t">
-            <a:normAutofit/>
+            <a:normAutofit fontScale="100000"/>
           </a:bodyPr>
           <a:lstStyle xmlns:a="http://schemas.openxmlformats.org/drawingml/2006/main"/>
           <a:p xmlns:a="http://schemas.openxmlformats.org/drawingml/2006/main">
@@ -23313,7 +23147,7 @@
                 <a:ea typeface="Aptos"/>
                 <a:cs typeface="Aptos"/>
               </a:rPr>
-              <a:t>Редован пројекат се развија у систему SCUTUM и наставља рад претходних генерација.</a:t>
+              <a:t>Редован пројекат развија се у систему SCUTUM и наставља рад претходних генерација.</a:t>
             </a:r>
           </a:p>
         </p:txBody>
@@ -23343,7 +23177,7 @@
             </a:avLst>
           </a:prstGeom>
           <a:solidFill xmlns:a="http://schemas.openxmlformats.org/drawingml/2006/main">
-            <a:srgbClr val="EEF3FF"/>
+            <a:srgbClr val="F7EFF1"/>
           </a:solidFill>
           <a:ln xmlns:a="http://schemas.openxmlformats.org/drawingml/2006/main" w="9525">
             <a:solidFill>
@@ -23409,7 +23243,7 @@
             <a:r>
               <a:rPr sz="1275" b="1">
                 <a:solidFill>
-                  <a:srgbClr val="2F5EF5"/>
+                  <a:srgbClr val="7A2636"/>
                 </a:solidFill>
                 <a:latin typeface="Aptos"/>
                 <a:ea typeface="Aptos"/>
@@ -24015,11 +23849,11 @@
             </a:avLst>
           </a:prstGeom>
           <a:solidFill xmlns:a="http://schemas.openxmlformats.org/drawingml/2006/main">
-            <a:srgbClr val="EEF3FF"/>
+            <a:srgbClr val="F7EFF1"/>
           </a:solidFill>
           <a:ln xmlns:a="http://schemas.openxmlformats.org/drawingml/2006/main" w="8573">
             <a:solidFill>
-              <a:srgbClr val="CAD7F2"/>
+              <a:srgbClr val="DBC7CC"/>
             </a:solidFill>
             <a:prstDash val="solid"/>
           </a:ln>
@@ -24050,7 +23884,7 @@
             </a:avLst>
           </a:prstGeom>
           <a:solidFill xmlns:a="http://schemas.openxmlformats.org/drawingml/2006/main">
-            <a:srgbClr val="2F5EF5"/>
+            <a:srgbClr val="7A2636"/>
           </a:solidFill>
           <a:ln xmlns:a="http://schemas.openxmlformats.org/drawingml/2006/main" w="0">
             <a:noFill/>
@@ -24091,6 +23925,7 @@
           <a:lstStyle xmlns:a="http://schemas.openxmlformats.org/drawingml/2006/main"/>
           <a:p xmlns:a="http://schemas.openxmlformats.org/drawingml/2006/main">
             <a:pPr>
+              <a:buNone/>
               <a:defRPr sz="1200" b="1">
                 <a:solidFill>
                   <a:srgbClr val="2F5EF5"/>
@@ -24103,7 +23938,7 @@
             <a:r>
               <a:rPr sz="1200" b="1">
                 <a:solidFill>
-                  <a:srgbClr val="2F5EF5"/>
+                  <a:srgbClr val="7A2636"/>
                 </a:solidFill>
                 <a:latin typeface="Aptos"/>
                 <a:ea typeface="Aptos"/>
@@ -24148,6 +23983,7 @@
           <a:lstStyle xmlns:a="http://schemas.openxmlformats.org/drawingml/2006/main"/>
           <a:p xmlns:a="http://schemas.openxmlformats.org/drawingml/2006/main">
             <a:pPr>
+              <a:buNone/>
               <a:defRPr sz="1350" b="1">
                 <a:solidFill>
                   <a:srgbClr val="1B2432"/>
@@ -24166,7 +24002,7 @@
                 <a:ea typeface="Aptos"/>
                 <a:cs typeface="Aptos"/>
               </a:rPr>
-              <a:t>Супер пројекат је практични део дипломског рада, непосредно повезан са информационом безбедношћу; тема и обим се утврђују пре почетка.</a:t>
+              <a:t>Супер пројекат је практични део дипломског рада, непосредно повезан са информационом безбедношћу. тема и обим се утврђују пре почетка.</a:t>
             </a:r>
           </a:p>
         </p:txBody>
@@ -24229,7 +24065,7 @@
         </p:spPr>
         <p:txBody>
           <a:bodyPr xmlns:a="http://schemas.openxmlformats.org/drawingml/2006/main" wrap="square" lIns="0" tIns="0" rIns="0" bIns="0" anchor="t">
-            <a:normAutofit/>
+            <a:normAutofit fontScale="100000"/>
           </a:bodyPr>
           <a:lstStyle xmlns:a="http://schemas.openxmlformats.org/drawingml/2006/main"/>
           <a:p xmlns:a="http://schemas.openxmlformats.org/drawingml/2006/main">
@@ -24250,7 +24086,7 @@
             <a:r>
               <a:rPr sz="825" b="0">
                 <a:solidFill>
-                  <a:srgbClr val="657184"/>
+                  <a:srgbClr val="5E6B7D"/>
                 </a:solidFill>
                 <a:latin typeface="Aptos"/>
                 <a:ea typeface="Aptos"/>
@@ -24283,10 +24119,12 @@
           <a:prstGeom xmlns:a="http://schemas.openxmlformats.org/drawingml/2006/main" prst="line">
             <a:avLst/>
           </a:prstGeom>
-          <a:noFill xmlns:a="http://schemas.openxmlformats.org/drawingml/2006/main"/>
-          <a:ln xmlns:a="http://schemas.openxmlformats.org/drawingml/2006/main" w="9525">
+          <a:solidFill xmlns:a="http://schemas.openxmlformats.org/drawingml/2006/main">
+            <a:srgbClr val="8D5560"/>
+          </a:solidFill>
+          <a:ln xmlns:a="http://schemas.openxmlformats.org/drawingml/2006/main" w="7144">
             <a:solidFill>
-              <a:srgbClr val="748092"/>
+              <a:srgbClr val="8D5560"/>
             </a:solidFill>
             <a:prstDash val="solid"/>
           </a:ln>
@@ -24382,7 +24220,7 @@
         </p:spPr>
         <p:txBody>
           <a:bodyPr xmlns:a="http://schemas.openxmlformats.org/drawingml/2006/main" wrap="square" lIns="0" tIns="0" rIns="0" bIns="0" anchor="t">
-            <a:normAutofit/>
+            <a:normAutofit fontScale="100000"/>
           </a:bodyPr>
           <a:lstStyle xmlns:a="http://schemas.openxmlformats.org/drawingml/2006/main"/>
           <a:p xmlns:a="http://schemas.openxmlformats.org/drawingml/2006/main">
@@ -24409,95 +24247,7 @@
                 <a:ea typeface="Aptos Display"/>
                 <a:cs typeface="Aptos Display"/>
               </a:rPr>
-              <a:t>Контролне</a:t>
-            </a:r>
-            <a:r>
-              <a:rPr sz="2550" b="1">
-                <a:solidFill>
-                  <a:srgbClr val="1A202C"/>
-                </a:solidFill>
-                <a:latin typeface="Aptos Display"/>
-                <a:ea typeface="Aptos Display"/>
-                <a:cs typeface="Aptos Display"/>
-              </a:rPr>
-              <a:t> </a:t>
-            </a:r>
-            <a:r>
-              <a:rPr sz="2550" b="1">
-                <a:solidFill>
-                  <a:srgbClr val="1A202C"/>
-                </a:solidFill>
-                <a:latin typeface="Aptos Display"/>
-                <a:ea typeface="Aptos Display"/>
-                <a:cs typeface="Aptos Display"/>
-              </a:rPr>
-              <a:t>тачке</a:t>
-            </a:r>
-            <a:r>
-              <a:rPr sz="2550" b="1">
-                <a:solidFill>
-                  <a:srgbClr val="1A202C"/>
-                </a:solidFill>
-                <a:latin typeface="Aptos Display"/>
-                <a:ea typeface="Aptos Display"/>
-                <a:cs typeface="Aptos Display"/>
-              </a:rPr>
-              <a:t> </a:t>
-            </a:r>
-            <a:r>
-              <a:rPr sz="2550" b="1">
-                <a:solidFill>
-                  <a:srgbClr val="1A202C"/>
-                </a:solidFill>
-                <a:latin typeface="Aptos Display"/>
-                <a:ea typeface="Aptos Display"/>
-                <a:cs typeface="Aptos Display"/>
-              </a:rPr>
-              <a:t>држе</a:t>
-            </a:r>
-            <a:r>
-              <a:rPr sz="2550" b="1">
-                <a:solidFill>
-                  <a:srgbClr val="1A202C"/>
-                </a:solidFill>
-                <a:latin typeface="Aptos Display"/>
-                <a:ea typeface="Aptos Display"/>
-                <a:cs typeface="Aptos Display"/>
-              </a:rPr>
-              <a:t> </a:t>
-            </a:r>
-            <a:r>
-              <a:rPr sz="2550" b="1">
-                <a:solidFill>
-                  <a:srgbClr val="1A202C"/>
-                </a:solidFill>
-                <a:latin typeface="Aptos Display"/>
-                <a:ea typeface="Aptos Display"/>
-                <a:cs typeface="Aptos Display"/>
-              </a:rPr>
-              <a:t>пројекат</a:t>
-            </a:r>
-            <a:r>
-              <a:rPr sz="2550" b="1">
-                <a:solidFill>
-                  <a:srgbClr val="1A202C"/>
-                </a:solidFill>
-                <a:latin typeface="Aptos Display"/>
-                <a:ea typeface="Aptos Display"/>
-                <a:cs typeface="Aptos Display"/>
-              </a:rPr>
-              <a:t> </a:t>
-            </a:r>
-            <a:r>
-              <a:rPr sz="2550" b="1">
-                <a:solidFill>
-                  <a:srgbClr val="1A202C"/>
-                </a:solidFill>
-                <a:latin typeface="Aptos Display"/>
-                <a:ea typeface="Aptos Display"/>
-                <a:cs typeface="Aptos Display"/>
-              </a:rPr>
-              <a:t>у континуитету</a:t>
+              <a:t>Контролне тачке пројекта</a:t>
             </a:r>
             <a:endParaRPr sz="2550" b="1">
               <a:solidFill>
@@ -24539,7 +24289,7 @@
         </p:spPr>
         <p:txBody>
           <a:bodyPr xmlns:a="http://schemas.openxmlformats.org/drawingml/2006/main" wrap="square" lIns="0" tIns="0" rIns="0" bIns="0" anchor="t">
-            <a:normAutofit/>
+            <a:normAutofit fontScale="100000"/>
           </a:bodyPr>
           <a:lstStyle xmlns:a="http://schemas.openxmlformats.org/drawingml/2006/main"/>
           <a:p xmlns:a="http://schemas.openxmlformats.org/drawingml/2006/main">
@@ -24566,7 +24316,7 @@
                 <a:ea typeface="Aptos"/>
                 <a:cs typeface="Aptos"/>
               </a:rPr>
-              <a:t>Одржавају се сваке друге рачунарске вежбе и проверавају унапред дефинисан напредак.</a:t>
+              <a:t>Контролне тачке одржавају се сваке друге рачунарске вежбе и проверавају унапред дефинисан напредак.</a:t>
             </a:r>
           </a:p>
         </p:txBody>
@@ -24596,7 +24346,7 @@
             </a:avLst>
           </a:prstGeom>
           <a:solidFill xmlns:a="http://schemas.openxmlformats.org/drawingml/2006/main">
-            <a:srgbClr val="EEF3FF"/>
+            <a:srgbClr val="F7EFF1"/>
           </a:solidFill>
           <a:ln xmlns:a="http://schemas.openxmlformats.org/drawingml/2006/main" w="9525">
             <a:solidFill>
@@ -24662,7 +24412,7 @@
             <a:r>
               <a:rPr sz="1238" b="1">
                 <a:solidFill>
-                  <a:srgbClr val="2F5EF5"/>
+                  <a:srgbClr val="7A2636"/>
                 </a:solidFill>
                 <a:latin typeface="Aptos"/>
                 <a:ea typeface="Aptos"/>
@@ -24820,7 +24570,7 @@
             </a:avLst>
           </a:prstGeom>
           <a:solidFill xmlns:a="http://schemas.openxmlformats.org/drawingml/2006/main">
-            <a:srgbClr val="F5F0FF"/>
+            <a:srgbClr val="F7F4F5"/>
           </a:solidFill>
           <a:ln xmlns:a="http://schemas.openxmlformats.org/drawingml/2006/main" w="9525">
             <a:solidFill>
@@ -24886,7 +24636,7 @@
             <a:r>
               <a:rPr sz="1238" b="1">
                 <a:solidFill>
-                  <a:srgbClr val="7651D4"/>
+                  <a:srgbClr val="7A2636"/>
                 </a:solidFill>
                 <a:latin typeface="Aptos"/>
                 <a:ea typeface="Aptos"/>
@@ -25469,7 +25219,7 @@
       </p:sp>
       <p:cxnSp>
         <p:nvCxnSpPr>
-          <p:cNvPr id="194" name="Straight Arrow Connector 97"/>
+          <p:cNvPr id="290" name="Straight Arrow Connector 97"/>
           <p:cNvCxnSpPr>
             <a:stCxn xmlns:a="http://schemas.openxmlformats.org/drawingml/2006/main" id="6" idx="3"/>
             <a:endCxn xmlns:a="http://schemas.openxmlformats.org/drawingml/2006/main" id="10" idx="1"/>
@@ -25495,7 +25245,7 @@
       </p:cxnSp>
       <p:cxnSp>
         <p:nvCxnSpPr>
-          <p:cNvPr id="195" name="Straight Arrow Connector 98"/>
+          <p:cNvPr id="291" name="Straight Arrow Connector 98"/>
           <p:cNvCxnSpPr>
             <a:stCxn xmlns:a="http://schemas.openxmlformats.org/drawingml/2006/main" id="10" idx="3"/>
             <a:endCxn xmlns:a="http://schemas.openxmlformats.org/drawingml/2006/main" id="14" idx="1"/>
@@ -25521,7 +25271,7 @@
       </p:cxnSp>
       <p:cxnSp>
         <p:nvCxnSpPr>
-          <p:cNvPr id="196" name="Straight Arrow Connector 99"/>
+          <p:cNvPr id="292" name="Straight Arrow Connector 99"/>
           <p:cNvCxnSpPr>
             <a:stCxn xmlns:a="http://schemas.openxmlformats.org/drawingml/2006/main" id="14" idx="3"/>
             <a:endCxn xmlns:a="http://schemas.openxmlformats.org/drawingml/2006/main" id="18" idx="1"/>
@@ -25821,7 +25571,7 @@
         </p:spPr>
         <p:txBody>
           <a:bodyPr xmlns:a="http://schemas.openxmlformats.org/drawingml/2006/main" wrap="square" lIns="0" tIns="0" rIns="0" bIns="0" anchor="t">
-            <a:normAutofit/>
+            <a:normAutofit fontScale="100000"/>
           </a:bodyPr>
           <a:lstStyle xmlns:a="http://schemas.openxmlformats.org/drawingml/2006/main"/>
           <a:p xmlns:a="http://schemas.openxmlformats.org/drawingml/2006/main">
@@ -25842,7 +25592,7 @@
             <a:r>
               <a:rPr sz="825" b="0">
                 <a:solidFill>
-                  <a:srgbClr val="657184"/>
+                  <a:srgbClr val="5E6B7D"/>
                 </a:solidFill>
                 <a:latin typeface="Aptos"/>
                 <a:ea typeface="Aptos"/>
@@ -25875,10 +25625,12 @@
           <a:prstGeom xmlns:a="http://schemas.openxmlformats.org/drawingml/2006/main" prst="line">
             <a:avLst/>
           </a:prstGeom>
-          <a:noFill xmlns:a="http://schemas.openxmlformats.org/drawingml/2006/main"/>
-          <a:ln xmlns:a="http://schemas.openxmlformats.org/drawingml/2006/main" w="9525">
+          <a:solidFill xmlns:a="http://schemas.openxmlformats.org/drawingml/2006/main">
+            <a:srgbClr val="8D5560"/>
+          </a:solidFill>
+          <a:ln xmlns:a="http://schemas.openxmlformats.org/drawingml/2006/main" w="7144">
             <a:solidFill>
-              <a:srgbClr val="748092"/>
+              <a:srgbClr val="8D5560"/>
             </a:solidFill>
             <a:prstDash val="solid"/>
           </a:ln>
@@ -25974,7 +25726,7 @@
         </p:spPr>
         <p:txBody>
           <a:bodyPr xmlns:a="http://schemas.openxmlformats.org/drawingml/2006/main" wrap="square" lIns="0" tIns="0" rIns="0" bIns="0" anchor="t">
-            <a:normAutofit/>
+            <a:normAutofit fontScale="100000"/>
           </a:bodyPr>
           <a:lstStyle xmlns:a="http://schemas.openxmlformats.org/drawingml/2006/main"/>
           <a:p xmlns:a="http://schemas.openxmlformats.org/drawingml/2006/main">
@@ -26001,7 +25753,7 @@
                 <a:ea typeface="Aptos Display"/>
                 <a:cs typeface="Aptos Display"/>
               </a:rPr>
-              <a:t>Одбрана, елиминациони тест и усмени</a:t>
+              <a:t>Компоненте испита</a:t>
             </a:r>
           </a:p>
         </p:txBody>
@@ -26035,7 +25787,7 @@
         </p:spPr>
         <p:txBody>
           <a:bodyPr xmlns:a="http://schemas.openxmlformats.org/drawingml/2006/main" wrap="square" lIns="0" tIns="0" rIns="0" bIns="0" anchor="t">
-            <a:normAutofit/>
+            <a:normAutofit fontScale="95238"/>
           </a:bodyPr>
           <a:lstStyle xmlns:a="http://schemas.openxmlformats.org/drawingml/2006/main"/>
           <a:p xmlns:a="http://schemas.openxmlformats.org/drawingml/2006/main">
@@ -26062,7 +25814,7 @@
                 <a:ea typeface="Aptos"/>
                 <a:cs typeface="Aptos"/>
               </a:rPr>
-              <a:t>Свака компонента проверава други слој знања: резултат, основне појмове и способност образлагања.</a:t>
+              <a:t>Одбрана пројекта, елиминациони тест и усмени испит проверавају различите аспекте знања и индивидуалног доприноса.</a:t>
             </a:r>
           </a:p>
         </p:txBody>
@@ -26092,7 +25844,7 @@
             </a:avLst>
           </a:prstGeom>
           <a:solidFill xmlns:a="http://schemas.openxmlformats.org/drawingml/2006/main">
-            <a:srgbClr val="EEF3FF"/>
+            <a:srgbClr val="F7EFF1"/>
           </a:solidFill>
           <a:ln xmlns:a="http://schemas.openxmlformats.org/drawingml/2006/main" w="9525">
             <a:solidFill>
@@ -26158,7 +25910,7 @@
             <a:r>
               <a:rPr sz="1275" b="1">
                 <a:solidFill>
-                  <a:srgbClr val="2F5EF5"/>
+                  <a:srgbClr val="7A2636"/>
                 </a:solidFill>
                 <a:latin typeface="Aptos"/>
                 <a:ea typeface="Aptos"/>
@@ -26978,7 +26730,7 @@
         </p:spPr>
         <p:txBody>
           <a:bodyPr xmlns:a="http://schemas.openxmlformats.org/drawingml/2006/main" wrap="square" lIns="0" tIns="0" rIns="0" bIns="0" anchor="t">
-            <a:normAutofit/>
+            <a:normAutofit fontScale="100000"/>
           </a:bodyPr>
           <a:lstStyle xmlns:a="http://schemas.openxmlformats.org/drawingml/2006/main"/>
           <a:p xmlns:a="http://schemas.openxmlformats.org/drawingml/2006/main">
@@ -26999,7 +26751,7 @@
             <a:r>
               <a:rPr sz="825" b="0">
                 <a:solidFill>
-                  <a:srgbClr val="657184"/>
+                  <a:srgbClr val="5E6B7D"/>
                 </a:solidFill>
                 <a:latin typeface="Aptos"/>
                 <a:ea typeface="Aptos"/>
@@ -27032,10 +26784,12 @@
           <a:prstGeom xmlns:a="http://schemas.openxmlformats.org/drawingml/2006/main" prst="line">
             <a:avLst/>
           </a:prstGeom>
-          <a:noFill xmlns:a="http://schemas.openxmlformats.org/drawingml/2006/main"/>
-          <a:ln xmlns:a="http://schemas.openxmlformats.org/drawingml/2006/main" w="9525">
+          <a:solidFill xmlns:a="http://schemas.openxmlformats.org/drawingml/2006/main">
+            <a:srgbClr val="8D5560"/>
+          </a:solidFill>
+          <a:ln xmlns:a="http://schemas.openxmlformats.org/drawingml/2006/main" w="7144">
             <a:solidFill>
-              <a:srgbClr val="748092"/>
+              <a:srgbClr val="8D5560"/>
             </a:solidFill>
             <a:prstDash val="solid"/>
           </a:ln>
@@ -27131,7 +26885,7 @@
         </p:spPr>
         <p:txBody>
           <a:bodyPr xmlns:a="http://schemas.openxmlformats.org/drawingml/2006/main" wrap="square" lIns="0" tIns="0" rIns="0" bIns="0" anchor="t">
-            <a:normAutofit/>
+            <a:normAutofit fontScale="100000"/>
           </a:bodyPr>
           <a:lstStyle xmlns:a="http://schemas.openxmlformats.org/drawingml/2006/main"/>
           <a:p xmlns:a="http://schemas.openxmlformats.org/drawingml/2006/main">
@@ -27158,7 +26912,7 @@
                 <a:ea typeface="Aptos Display"/>
                 <a:cs typeface="Aptos Display"/>
               </a:rPr>
-              <a:t>Осам вежби прати природан ток безбедносног размишљања</a:t>
+              <a:t>Теме рачунарских вежби</a:t>
             </a:r>
           </a:p>
         </p:txBody>
@@ -27192,7 +26946,7 @@
         </p:spPr>
         <p:txBody>
           <a:bodyPr xmlns:a="http://schemas.openxmlformats.org/drawingml/2006/main" wrap="square" lIns="0" tIns="0" rIns="0" bIns="0" anchor="t">
-            <a:normAutofit/>
+            <a:normAutofit fontScale="96236"/>
           </a:bodyPr>
           <a:lstStyle xmlns:a="http://schemas.openxmlformats.org/drawingml/2006/main"/>
           <a:p xmlns:a="http://schemas.openxmlformats.org/drawingml/2006/main">
@@ -27219,7 +26973,7 @@
                 <a:ea typeface="Aptos"/>
                 <a:cs typeface="Aptos"/>
               </a:rPr>
-              <a:t>Од идентитета и приступа до оперативне реакције, ризика и мерења ефективности.</a:t>
+              <a:t>Осам вежби обухвата контролу приступа, оперативну безбедност, процену ризика и проверу ефективности контрола.</a:t>
             </a:r>
           </a:p>
         </p:txBody>
@@ -27249,7 +27003,7 @@
             </a:avLst>
           </a:prstGeom>
           <a:solidFill xmlns:a="http://schemas.openxmlformats.org/drawingml/2006/main">
-            <a:srgbClr val="EEF3FF"/>
+            <a:srgbClr val="F7EFF1"/>
           </a:solidFill>
           <a:ln xmlns:a="http://schemas.openxmlformats.org/drawingml/2006/main" w="9525">
             <a:solidFill>
@@ -27309,7 +27063,7 @@
             <a:r>
               <a:rPr sz="1275" b="1">
                 <a:solidFill>
-                  <a:srgbClr val="2F5EF5"/>
+                  <a:srgbClr val="7A2636"/>
                 </a:solidFill>
                 <a:latin typeface="Aptos"/>
                 <a:ea typeface="Aptos"/>
@@ -27563,7 +27317,7 @@
             </a:avLst>
           </a:prstGeom>
           <a:solidFill xmlns:a="http://schemas.openxmlformats.org/drawingml/2006/main">
-            <a:srgbClr val="F5F0FF"/>
+            <a:srgbClr val="F7F4F5"/>
           </a:solidFill>
           <a:ln xmlns:a="http://schemas.openxmlformats.org/drawingml/2006/main" w="9525">
             <a:solidFill>
@@ -27623,7 +27377,7 @@
             <a:r>
               <a:rPr sz="1275" b="1">
                 <a:solidFill>
-                  <a:srgbClr val="7651D4"/>
+                  <a:srgbClr val="7A2636"/>
                 </a:solidFill>
                 <a:latin typeface="Aptos"/>
                 <a:ea typeface="Aptos"/>
@@ -27877,7 +27631,7 @@
             </a:avLst>
           </a:prstGeom>
           <a:solidFill xmlns:a="http://schemas.openxmlformats.org/drawingml/2006/main">
-            <a:srgbClr val="EEF3FF"/>
+            <a:srgbClr val="F7EFF1"/>
           </a:solidFill>
           <a:ln xmlns:a="http://schemas.openxmlformats.org/drawingml/2006/main" w="9525">
             <a:solidFill>
@@ -27937,7 +27691,7 @@
             <a:r>
               <a:rPr sz="1275" b="1">
                 <a:solidFill>
-                  <a:srgbClr val="2F5EF5"/>
+                  <a:srgbClr val="7A2636"/>
                 </a:solidFill>
                 <a:latin typeface="Aptos"/>
                 <a:ea typeface="Aptos"/>
@@ -28191,7 +27945,7 @@
             </a:avLst>
           </a:prstGeom>
           <a:solidFill xmlns:a="http://schemas.openxmlformats.org/drawingml/2006/main">
-            <a:srgbClr val="F5F0FF"/>
+            <a:srgbClr val="F7F4F5"/>
           </a:solidFill>
           <a:ln xmlns:a="http://schemas.openxmlformats.org/drawingml/2006/main" w="9525">
             <a:solidFill>
@@ -28251,7 +28005,7 @@
             <a:r>
               <a:rPr sz="1275" b="1">
                 <a:solidFill>
-                  <a:srgbClr val="7651D4"/>
+                  <a:srgbClr val="7A2636"/>
                 </a:solidFill>
                 <a:latin typeface="Aptos"/>
                 <a:ea typeface="Aptos"/>
@@ -28505,11 +28259,11 @@
             </a:avLst>
           </a:prstGeom>
           <a:solidFill xmlns:a="http://schemas.openxmlformats.org/drawingml/2006/main">
-            <a:srgbClr val="EEF3FF"/>
+            <a:srgbClr val="F7EFF1"/>
           </a:solidFill>
           <a:ln xmlns:a="http://schemas.openxmlformats.org/drawingml/2006/main" w="8573">
             <a:solidFill>
-              <a:srgbClr val="CAD7F2"/>
+              <a:srgbClr val="DBC7CC"/>
             </a:solidFill>
             <a:prstDash val="solid"/>
           </a:ln>
@@ -28540,7 +28294,7 @@
             </a:avLst>
           </a:prstGeom>
           <a:solidFill xmlns:a="http://schemas.openxmlformats.org/drawingml/2006/main">
-            <a:srgbClr val="2F5EF5"/>
+            <a:srgbClr val="7A2636"/>
           </a:solidFill>
           <a:ln xmlns:a="http://schemas.openxmlformats.org/drawingml/2006/main" w="0">
             <a:noFill/>
@@ -28581,6 +28335,7 @@
           <a:lstStyle xmlns:a="http://schemas.openxmlformats.org/drawingml/2006/main"/>
           <a:p xmlns:a="http://schemas.openxmlformats.org/drawingml/2006/main">
             <a:pPr>
+              <a:buNone/>
               <a:defRPr sz="1200" b="1">
                 <a:solidFill>
                   <a:srgbClr val="2854D7"/>
@@ -28593,7 +28348,7 @@
             <a:r>
               <a:rPr sz="1200" b="1">
                 <a:solidFill>
-                  <a:srgbClr val="2854D7"/>
+                  <a:srgbClr val="7A2636"/>
                 </a:solidFill>
                 <a:latin typeface="Aptos"/>
                 <a:ea typeface="Aptos"/>
@@ -28638,6 +28393,7 @@
           <a:lstStyle xmlns:a="http://schemas.openxmlformats.org/drawingml/2006/main"/>
           <a:p xmlns:a="http://schemas.openxmlformats.org/drawingml/2006/main">
             <a:pPr>
+              <a:buNone/>
               <a:defRPr sz="1350" b="1">
                 <a:solidFill>
                   <a:srgbClr val="1B2432"/>

</xml_diff>

<commit_message>
Align OIB decks with the examples and hold checkpoints every second exercise
Code slides in OIB decks 01-08 now quote the exercise code and its NUnit
tests, concept slides carry statements specific to each concept, and line
numbers stay level with the code. The intro deck lists checkpoints after
exercises 2, 4, 6 and 8 and names the live portal address.
</commit_message>
<xml_diff>
--- a/02 Osnove Informacione Bezbednosti/02 Prezentacije/PPTX/00_Osnovne_informacije.pptx
+++ b/02 Osnove Informacione Bezbednosti/02 Prezentacije/PPTX/00_Osnovne_informacije.pptx
@@ -11003,7 +11003,7 @@
                 <a:ea typeface="Aptos"/>
                 <a:cs typeface="Aptos"/>
               </a:rPr>
-              <a:t>После вежбе 3</a:t>
+              <a:t>После вежби 3–4</a:t>
             </a:r>
           </a:p>
         </p:txBody>
@@ -11227,7 +11227,7 @@
                 <a:ea typeface="Aptos"/>
                 <a:cs typeface="Aptos"/>
               </a:rPr>
-              <a:t>После вежбе 4</a:t>
+              <a:t>После вежби 5–6</a:t>
             </a:r>
           </a:p>
         </p:txBody>
@@ -11451,7 +11451,7 @@
                 <a:ea typeface="Aptos"/>
                 <a:cs typeface="Aptos"/>
               </a:rPr>
-              <a:t>После вежби 5–8</a:t>
+              <a:t>После вежби 7–8</a:t>
             </a:r>
           </a:p>
         </p:txBody>
@@ -14749,7 +14749,7 @@
                 <a:ea typeface="Aptos"/>
                 <a:cs typeface="Aptos"/>
               </a:rPr>
-              <a:t>Јединствени материјали за рачунарске вежбе доступни су на ftn-predmeti.vercel.app/#oib.</a:t>
+              <a:t>Јединствени материјали за рачунарске вежбе доступни су на ftn-nastavni-portal.vercel.app/#oib.</a:t>
             </a:r>
           </a:p>
         </p:txBody>

</xml_diff>